<commit_message>
Fix visual defects found by QA in the figures and the deck
Deck: passing w/h alongside a placeholder is ignored by pptxgenjs, so the body text on the two
two-column slides ran full width underneath the side panels and was cut off - replaced with
explicit text boxes. Also moved the takeaway clear of the stat tiles, gave the MPRA tiles room
for their captions, and aligned the title rule.

Figures: legend no longer covers the MEF2 row in the partner ranking (38); heatmap gridlines no
longer strike through the cell values and dark cells get white text (46, 47); the zero line no
longer crosses the titration legend (47); the reference-line label no longer collides with the
Age Up interval (48); partner chips are now sized to their labels instead of clipping them (49).

Co-Authored-By: Claude Opus 5 <noreply@anthropic.com>
</commit_message>
<xml_diff>
--- a/Analysis/AP1_AlphaGenome_results.pptx
+++ b/Analysis/AP1_AlphaGenome_results.pptx
@@ -118,17 +118,17 @@
   <p:extLst>
     <p:ext uri="{521415D9-36F7-43E2-AB2F-B90AF26B5E84}">
       <p14:sectionLst xmlns:p14="http://schemas.microsoft.com/office/powerpoint/2010/main">
-        <p14:section name="Opening" id="{a33bfdfe-1127-c08a-71ca-71cc907b92dc}">
+        <p14:section name="Opening" id="{ff433115-9018-34ee-f477-cd82dbf7be35}">
           <p14:sldIdLst>
             <p14:sldId id="256"/>
           </p14:sldIdLst>
         </p14:section>
-        <p14:section name="Design" id="{fc9e2001-5d38-295c-ba9a-dc062a776286}">
+        <p14:section name="Design" id="{bda7a694-89d3-613e-0e28-a6ac29cee23c}">
           <p14:sldIdLst>
             <p14:sldId id="257"/>
           </p14:sldIdLst>
         </p14:section>
-        <p14:section name="Findings" id="{028c7b16-5f1c-943d-d73a-b99a79e97881}">
+        <p14:section name="Findings" id="{7fb85f0c-cd5e-446e-1c11-2933e4705097}">
           <p14:sldIdLst>
             <p14:sldId id="258"/>
             <p14:sldId id="259"/>
@@ -140,7 +140,7 @@
             <p14:sldId id="265"/>
           </p14:sldIdLst>
         </p14:section>
-        <p14:section name="Conclusion" id="{19910ed1-e335-6f9d-b935-56d2257b769e}">
+        <p14:section name="Conclusion" id="{afde0942-2935-4f67-ce67-4b9029a80c3f}">
           <p14:sldIdLst>
             <p14:sldId id="266"/>
             <p14:sldId id="267"/>
@@ -1671,7 +1671,7 @@
         </p:nvSpPr>
         <p:spPr>
           <a:xfrm>
-            <a:off x="822960" y="3611880"/>
+            <a:off x="822960" y="3703320"/>
             <a:ext cx="10515600" cy="1371600"/>
           </a:xfrm>
           <a:prstGeom prst="rect">
@@ -2448,7 +2448,7 @@
         </p:nvSpPr>
         <p:spPr>
           <a:xfrm>
-            <a:off x="822960" y="3611880"/>
+            <a:off x="822960" y="3703320"/>
             <a:ext cx="10515600" cy="1371600"/>
           </a:xfrm>
           <a:prstGeom prst="rect">
@@ -2498,8 +2498,8 @@
         </p:nvSpPr>
         <p:spPr>
           <a:xfrm>
-            <a:off x="822960" y="2011680"/>
-            <a:ext cx="2194560" cy="0"/>
+            <a:off x="896112" y="3493008"/>
+            <a:ext cx="2011680" cy="0"/>
           </a:xfrm>
           <a:prstGeom prst="line">
             <a:avLst/>
@@ -2592,7 +2592,7 @@
         </p:blipFill>
         <p:spPr>
           <a:xfrm>
-            <a:off x="502920" y="1828800"/>
+            <a:off x="502920" y="2377440"/>
             <a:ext cx="11155680" cy="3383280"/>
           </a:xfrm>
           <a:prstGeom prst="rect">
@@ -2609,11 +2609,11 @@
         <p:spPr>
           <a:xfrm>
             <a:off x="502920" y="1097280"/>
-            <a:ext cx="5440680" cy="658368"/>
+            <a:ext cx="5440680" cy="1051560"/>
           </a:xfrm>
           <a:prstGeom prst="roundRect">
             <a:avLst>
-              <a:gd name="adj" fmla="val 8333"/>
+              <a:gd name="adj" fmla="val 5217"/>
             </a:avLst>
           </a:prstGeom>
           <a:solidFill>
@@ -2672,7 +2672,7 @@
         <p:spPr>
           <a:xfrm>
             <a:off x="612648" y="1755648"/>
-            <a:ext cx="5221224" cy="-73152"/>
+            <a:ext cx="5221224" cy="320040"/>
           </a:xfrm>
           <a:prstGeom prst="rect">
             <a:avLst/>
@@ -2708,11 +2708,11 @@
         <p:spPr>
           <a:xfrm>
             <a:off x="6217920" y="1097280"/>
-            <a:ext cx="5440680" cy="658368"/>
+            <a:ext cx="5440680" cy="1051560"/>
           </a:xfrm>
           <a:prstGeom prst="roundRect">
             <a:avLst>
-              <a:gd name="adj" fmla="val 8333"/>
+              <a:gd name="adj" fmla="val 5217"/>
             </a:avLst>
           </a:prstGeom>
           <a:solidFill>
@@ -2771,7 +2771,7 @@
         <p:spPr>
           <a:xfrm>
             <a:off x="6327648" y="1755648"/>
-            <a:ext cx="5221224" cy="-73152"/>
+            <a:ext cx="5221224" cy="320040"/>
           </a:xfrm>
           <a:prstGeom prst="rect">
             <a:avLst/>
@@ -3401,16 +3401,14 @@
       </p:sp>
       <p:sp>
         <p:nvSpPr>
-          <p:cNvPr id="3" name="Text 0"/>
-          <p:cNvSpPr/>
-          <p:nvPr>
-            <p:ph idx="101" type="body" hasCustomPrompt="1"/>
-          </p:nvPr>
+          <p:cNvPr id="3" name="Text 1"/>
+          <p:cNvSpPr txBox="1"/>
+          <p:nvPr/>
         </p:nvSpPr>
         <p:spPr>
           <a:xfrm>
             <a:off x="502920" y="1234440"/>
-            <a:ext cx="11155680" cy="5120640"/>
+            <a:ext cx="5760720" cy="3657600"/>
           </a:xfrm>
           <a:prstGeom prst="rect">
             <a:avLst/>
@@ -3419,16 +3417,16 @@
           <a:ln/>
         </p:spPr>
         <p:txBody>
-          <a:bodyPr wrap="square" rtlCol="0" anchor="t"/>
-          <a:lstStyle/>
-          <a:p>
-            <a:pPr algn="l" indent="0" marL="0">
+          <a:bodyPr wrap="square" lIns="0" tIns="0" rIns="0" bIns="0" rtlCol="0" anchor="ctr"/>
+          <a:lstStyle/>
+          <a:p>
+            <a:pPr indent="0" marL="0">
               <a:buNone/>
             </a:pPr>
             <a:r>
               <a:rPr lang="en-US" sz="1900" b="1" dirty="0">
                 <a:solidFill>
-                  <a:schemeClr val="tx1"/>
+                  <a:srgbClr val="111111"/>
                 </a:solidFill>
               </a:rPr>
               <a:t>Threshold (binary call)</a:t>
@@ -3436,7 +3434,7 @@
             <a:endParaRPr lang="en-US" sz="1700" dirty="0"/>
           </a:p>
           <a:p>
-            <a:pPr algn="l" indent="0" marL="0">
+            <a:pPr indent="0" marL="0">
               <a:spcAft>
                 <a:spcPts val="1400"/>
               </a:spcAft>
@@ -3445,7 +3443,7 @@
             <a:r>
               <a:rPr lang="en-US" sz="1700" dirty="0">
                 <a:solidFill>
-                  <a:schemeClr val="tx1"/>
+                  <a:srgbClr val="111111"/>
                 </a:solidFill>
               </a:rPr>
               <a:t>The TOBIAS footprint is absent in young and called in aged. 396 Age Up sites, 179 Age Down. Stable = called in all three conditions.</a:t>
@@ -3453,13 +3451,13 @@
             <a:endParaRPr lang="en-US" sz="1700" dirty="0"/>
           </a:p>
           <a:p>
-            <a:pPr algn="l" indent="0" marL="0">
+            <a:pPr indent="0" marL="0">
               <a:buNone/>
             </a:pPr>
             <a:r>
               <a:rPr lang="en-US" sz="1900" b="1" dirty="0">
                 <a:solidFill>
-                  <a:schemeClr val="tx1"/>
+                  <a:srgbClr val="111111"/>
                 </a:solidFill>
               </a:rPr>
               <a:t>Δscore (graded)</a:t>
@@ -3467,7 +3465,7 @@
             <a:endParaRPr lang="en-US" sz="1700" dirty="0"/>
           </a:p>
           <a:p>
-            <a:pPr algn="l" indent="0" marL="0">
+            <a:pPr indent="0" marL="0">
               <a:spcAft>
                 <a:spcPts val="1400"/>
               </a:spcAft>
@@ -3476,7 +3474,7 @@
             <a:r>
               <a:rPr lang="en-US" sz="1700" dirty="0">
                 <a:solidFill>
-                  <a:schemeClr val="tx1"/>
+                  <a:srgbClr val="111111"/>
                 </a:solidFill>
               </a:rPr>
               <a:t>The top fifth of the change in binding score, whether or not the call ever crossed the line. 736 sites each way.</a:t>
@@ -3484,7 +3482,7 @@
             <a:endParaRPr lang="en-US" sz="1700" dirty="0"/>
           </a:p>
           <a:p>
-            <a:pPr algn="l" indent="0" marL="0">
+            <a:pPr indent="0" marL="0">
               <a:buNone/>
             </a:pPr>
             <a:r>
@@ -3507,12 +3505,12 @@
         </p:nvSpPr>
         <p:spPr>
           <a:xfrm>
-            <a:off x="502920" y="5029200"/>
-            <a:ext cx="5440680" cy="1188720"/>
+            <a:off x="502920" y="5074920"/>
+            <a:ext cx="5440680" cy="1234440"/>
           </a:xfrm>
           <a:prstGeom prst="roundRect">
             <a:avLst>
-              <a:gd name="adj" fmla="val 4615"/>
+              <a:gd name="adj" fmla="val 4444"/>
             </a:avLst>
           </a:prstGeom>
           <a:solidFill>
@@ -3534,7 +3532,7 @@
         </p:nvSpPr>
         <p:spPr>
           <a:xfrm>
-            <a:off x="612648" y="5120640"/>
+            <a:off x="612648" y="5166360"/>
             <a:ext cx="5221224" cy="548640"/>
           </a:xfrm>
           <a:prstGeom prst="rect">
@@ -3570,8 +3568,8 @@
         </p:nvSpPr>
         <p:spPr>
           <a:xfrm>
-            <a:off x="612648" y="5687568"/>
-            <a:ext cx="5221224" cy="457200"/>
+            <a:off x="612648" y="5733288"/>
+            <a:ext cx="5221224" cy="502920"/>
           </a:xfrm>
           <a:prstGeom prst="rect">
             <a:avLst/>
@@ -3592,21 +3590,7 @@
                   <a:srgbClr val="595959"/>
                 </a:solidFill>
               </a:rPr>
-              <a:t>Δscore vs measured</a:t>
-            </a:r>
-            <a:endParaRPr lang="en-US" sz="1200" dirty="0"/>
-          </a:p>
-          <a:p>
-            <a:pPr algn="ctr" indent="0" marL="0">
-              <a:buNone/>
-            </a:pPr>
-            <a:r>
-              <a:rPr lang="en-US" sz="1200" dirty="0">
-                <a:solidFill>
-                  <a:srgbClr val="595959"/>
-                </a:solidFill>
-              </a:rPr>
-              <a:t>snATAC change (age)</a:t>
+              <a:t>Δscore vs measured snATAC change (age)</a:t>
             </a:r>
             <a:endParaRPr lang="en-US" sz="1200" dirty="0"/>
           </a:p>
@@ -3620,12 +3604,12 @@
         </p:nvSpPr>
         <p:spPr>
           <a:xfrm>
-            <a:off x="6217920" y="5029200"/>
-            <a:ext cx="5440680" cy="1188720"/>
+            <a:off x="6217920" y="5074920"/>
+            <a:ext cx="5440680" cy="1234440"/>
           </a:xfrm>
           <a:prstGeom prst="roundRect">
             <a:avLst>
-              <a:gd name="adj" fmla="val 4615"/>
+              <a:gd name="adj" fmla="val 4444"/>
             </a:avLst>
           </a:prstGeom>
           <a:solidFill>
@@ -3647,7 +3631,7 @@
         </p:nvSpPr>
         <p:spPr>
           <a:xfrm>
-            <a:off x="6327648" y="5120640"/>
+            <a:off x="6327648" y="5166360"/>
             <a:ext cx="5221224" cy="548640"/>
           </a:xfrm>
           <a:prstGeom prst="rect">
@@ -3683,8 +3667,8 @@
         </p:nvSpPr>
         <p:spPr>
           <a:xfrm>
-            <a:off x="6327648" y="5687568"/>
-            <a:ext cx="5221224" cy="457200"/>
+            <a:off x="6327648" y="5733288"/>
+            <a:ext cx="5221224" cy="502920"/>
           </a:xfrm>
           <a:prstGeom prst="rect">
             <a:avLst/>
@@ -3705,21 +3689,7 @@
                   <a:srgbClr val="595959"/>
                 </a:solidFill>
               </a:rPr>
-              <a:t>threshold class vs</a:t>
-            </a:r>
-            <a:endParaRPr lang="en-US" sz="1200" dirty="0"/>
-          </a:p>
-          <a:p>
-            <a:pPr algn="ctr" indent="0" marL="0">
-              <a:buNone/>
-            </a:pPr>
-            <a:r>
-              <a:rPr lang="en-US" sz="1200" dirty="0">
-                <a:solidFill>
-                  <a:srgbClr val="595959"/>
-                </a:solidFill>
-              </a:rPr>
-              <a:t>measured change</a:t>
+              <a:t>threshold class vs measured change</a:t>
             </a:r>
             <a:endParaRPr lang="en-US" sz="1200" dirty="0"/>
           </a:p>
@@ -3771,8 +3741,8 @@
         </p:nvSpPr>
         <p:spPr>
           <a:xfrm>
-            <a:off x="6492240" y="3749040"/>
-            <a:ext cx="5166360" cy="914400"/>
+            <a:off x="6492240" y="3886200"/>
+            <a:ext cx="5166360" cy="822960"/>
           </a:xfrm>
           <a:prstGeom prst="rect">
             <a:avLst/>
@@ -3796,6 +3766,36 @@
               <a:t>The Δscore definition tracks the measured data about twice as well.</a:t>
             </a:r>
             <a:endParaRPr lang="en-US" sz="1500" dirty="0"/>
+          </a:p>
+        </p:txBody>
+      </p:sp>
+      <p:sp>
+        <p:nvSpPr>
+          <p:cNvPr id="13" name="Text 0"/>
+          <p:cNvSpPr/>
+          <p:nvPr>
+            <p:ph idx="101" type="body" hasCustomPrompt="1"/>
+          </p:nvPr>
+        </p:nvSpPr>
+        <p:spPr>
+          <a:xfrm>
+            <a:off x="502920" y="1234440"/>
+            <a:ext cx="11155680" cy="5120640"/>
+          </a:xfrm>
+          <a:prstGeom prst="rect">
+            <a:avLst/>
+          </a:prstGeom>
+          <a:noFill/>
+          <a:ln/>
+        </p:spPr>
+        <p:txBody>
+          <a:bodyPr wrap="square" rtlCol="0" anchor="t"/>
+          <a:lstStyle/>
+          <a:p>
+            <a:pPr algn="l" indent="0" marL="0">
+              <a:buNone/>
+            </a:pPr>
+            <a:endParaRPr lang="en-US" sz="1700" dirty="0"/>
           </a:p>
         </p:txBody>
       </p:sp>
@@ -4104,8 +4104,8 @@
         </p:blipFill>
         <p:spPr>
           <a:xfrm>
-            <a:off x="685800" y="1051560"/>
-            <a:ext cx="7589520" cy="4617720"/>
+            <a:off x="502920" y="1097280"/>
+            <a:ext cx="7498080" cy="4572000"/>
           </a:xfrm>
           <a:prstGeom prst="rect">
             <a:avLst/>
@@ -4120,8 +4120,8 @@
         </p:nvSpPr>
         <p:spPr>
           <a:xfrm>
-            <a:off x="8503920" y="1463040"/>
-            <a:ext cx="3154680" cy="3291840"/>
+            <a:off x="8275320" y="1554480"/>
+            <a:ext cx="3383280" cy="3474720"/>
           </a:xfrm>
           <a:prstGeom prst="rect">
             <a:avLst/>
@@ -4912,7 +4912,7 @@
         </p:blipFill>
         <p:spPr>
           <a:xfrm>
-            <a:off x="502920" y="1691640"/>
+            <a:off x="502920" y="1234440"/>
             <a:ext cx="11155680" cy="3246120"/>
           </a:xfrm>
           <a:prstGeom prst="rect">
@@ -4928,7 +4928,7 @@
         </p:nvSpPr>
         <p:spPr>
           <a:xfrm>
-            <a:off x="502920" y="5074920"/>
+            <a:off x="502920" y="4709160"/>
             <a:ext cx="2583180" cy="1051560"/>
           </a:xfrm>
           <a:prstGeom prst="roundRect">
@@ -4955,7 +4955,7 @@
         </p:nvSpPr>
         <p:spPr>
           <a:xfrm>
-            <a:off x="612648" y="5166360"/>
+            <a:off x="612648" y="4800600"/>
             <a:ext cx="2363724" cy="548640"/>
           </a:xfrm>
           <a:prstGeom prst="rect">
@@ -4991,7 +4991,7 @@
         </p:nvSpPr>
         <p:spPr>
           <a:xfrm>
-            <a:off x="612648" y="5733288"/>
+            <a:off x="612648" y="5367528"/>
             <a:ext cx="2363724" cy="320040"/>
           </a:xfrm>
           <a:prstGeom prst="rect">
@@ -5027,7 +5027,7 @@
         </p:nvSpPr>
         <p:spPr>
           <a:xfrm>
-            <a:off x="3360420" y="5074920"/>
+            <a:off x="3360420" y="4709160"/>
             <a:ext cx="2583180" cy="1051560"/>
           </a:xfrm>
           <a:prstGeom prst="roundRect">
@@ -5054,7 +5054,7 @@
         </p:nvSpPr>
         <p:spPr>
           <a:xfrm>
-            <a:off x="3470148" y="5166360"/>
+            <a:off x="3470148" y="4800600"/>
             <a:ext cx="2363724" cy="548640"/>
           </a:xfrm>
           <a:prstGeom prst="rect">
@@ -5090,7 +5090,7 @@
         </p:nvSpPr>
         <p:spPr>
           <a:xfrm>
-            <a:off x="3470148" y="5733288"/>
+            <a:off x="3470148" y="5367528"/>
             <a:ext cx="2363724" cy="320040"/>
           </a:xfrm>
           <a:prstGeom prst="rect">
@@ -5126,7 +5126,7 @@
         </p:nvSpPr>
         <p:spPr>
           <a:xfrm>
-            <a:off x="6217920" y="5074920"/>
+            <a:off x="6217920" y="4709160"/>
             <a:ext cx="2583180" cy="1051560"/>
           </a:xfrm>
           <a:prstGeom prst="roundRect">
@@ -5153,7 +5153,7 @@
         </p:nvSpPr>
         <p:spPr>
           <a:xfrm>
-            <a:off x="6327648" y="5166360"/>
+            <a:off x="6327648" y="4800600"/>
             <a:ext cx="2363724" cy="548640"/>
           </a:xfrm>
           <a:prstGeom prst="rect">
@@ -5189,7 +5189,7 @@
         </p:nvSpPr>
         <p:spPr>
           <a:xfrm>
-            <a:off x="6327648" y="5733288"/>
+            <a:off x="6327648" y="5367528"/>
             <a:ext cx="2363724" cy="320040"/>
           </a:xfrm>
           <a:prstGeom prst="rect">
@@ -5225,7 +5225,7 @@
         </p:nvSpPr>
         <p:spPr>
           <a:xfrm>
-            <a:off x="9075420" y="5074920"/>
+            <a:off x="9075420" y="4709160"/>
             <a:ext cx="2583180" cy="1051560"/>
           </a:xfrm>
           <a:prstGeom prst="roundRect">
@@ -5252,7 +5252,7 @@
         </p:nvSpPr>
         <p:spPr>
           <a:xfrm>
-            <a:off x="9185148" y="5166360"/>
+            <a:off x="9185148" y="4800600"/>
             <a:ext cx="2363724" cy="548640"/>
           </a:xfrm>
           <a:prstGeom prst="rect">
@@ -5288,7 +5288,7 @@
         </p:nvSpPr>
         <p:spPr>
           <a:xfrm>
-            <a:off x="9185148" y="5733288"/>
+            <a:off x="9185148" y="5367528"/>
             <a:ext cx="2363724" cy="320040"/>
           </a:xfrm>
           <a:prstGeom prst="rect">
@@ -5475,16 +5475,14 @@
       </p:sp>
       <p:sp>
         <p:nvSpPr>
-          <p:cNvPr id="3" name="Text 0"/>
-          <p:cNvSpPr/>
-          <p:nvPr>
-            <p:ph idx="101" type="body" hasCustomPrompt="1"/>
-          </p:nvPr>
+          <p:cNvPr id="3" name="Text 1"/>
+          <p:cNvSpPr txBox="1"/>
+          <p:nvPr/>
         </p:nvSpPr>
         <p:spPr>
           <a:xfrm>
             <a:off x="502920" y="1234440"/>
-            <a:ext cx="11155680" cy="5120640"/>
+            <a:ext cx="6720840" cy="3657600"/>
           </a:xfrm>
           <a:prstGeom prst="rect">
             <a:avLst/>
@@ -5493,10 +5491,10 @@
           <a:ln/>
         </p:spPr>
         <p:txBody>
-          <a:bodyPr wrap="square" rtlCol="0" anchor="t"/>
-          <a:lstStyle/>
-          <a:p>
-            <a:pPr algn="l" indent="0" marL="0">
+          <a:bodyPr wrap="square" lIns="0" tIns="0" rIns="0" bIns="0" rtlCol="0" anchor="ctr"/>
+          <a:lstStyle/>
+          <a:p>
+            <a:pPr indent="0" marL="0">
               <a:spcAft>
                 <a:spcPts val="1600"/>
               </a:spcAft>
@@ -5505,7 +5503,7 @@
             <a:r>
               <a:rPr lang="en-US" sz="1700" dirty="0">
                 <a:solidFill>
-                  <a:schemeClr val="tx1"/>
+                  <a:srgbClr val="111111"/>
                 </a:solidFill>
               </a:rPr>
               <a:t>Sites in the top fifth of binding-score gain with age differ from matched controls in four ways, and they all point the same direction:</a:t>
@@ -5513,14 +5511,14 @@
             <a:endParaRPr lang="en-US" sz="1700" dirty="0"/>
           </a:p>
           <a:p>
-            <a:pPr algn="l" marL="342900" indent="-342900">
+            <a:pPr marL="342900" indent="-342900">
               <a:buSzPct val="100000"/>
               <a:buChar char="•"/>
             </a:pPr>
             <a:r>
               <a:rPr lang="en-US" sz="1700" dirty="0">
                 <a:solidFill>
-                  <a:schemeClr val="tx1"/>
+                  <a:srgbClr val="111111"/>
                 </a:solidFill>
               </a:rPr>
               <a:t>They gain more from an added motif copy  (+0.38 vs +0.32, FDR &lt; 0.001)</a:t>
@@ -5528,14 +5526,14 @@
             <a:endParaRPr lang="en-US" sz="1700" dirty="0"/>
           </a:p>
           <a:p>
-            <a:pPr algn="l" marL="342900" indent="-342900">
+            <a:pPr marL="342900" indent="-342900">
               <a:buSzPct val="100000"/>
               <a:buChar char="•"/>
             </a:pPr>
             <a:r>
               <a:rPr lang="en-US" sz="1700" dirty="0">
                 <a:solidFill>
-                  <a:schemeClr val="tx1"/>
+                  <a:srgbClr val="111111"/>
                 </a:solidFill>
               </a:rPr>
               <a:t>They benefit more when that copy is near  (FDR 0.003)</a:t>
@@ -5543,14 +5541,14 @@
             <a:endParaRPr lang="en-US" sz="1700" dirty="0"/>
           </a:p>
           <a:p>
-            <a:pPr algn="l" marL="342900" indent="-342900">
+            <a:pPr marL="342900" indent="-342900">
               <a:buSzPct val="100000"/>
               <a:buChar char="•"/>
             </a:pPr>
             <a:r>
               <a:rPr lang="en-US" sz="1700" dirty="0">
                 <a:solidFill>
-                  <a:schemeClr val="tx1"/>
+                  <a:srgbClr val="111111"/>
                 </a:solidFill>
               </a:rPr>
               <a:t>They lose more from one damaged core base  (−0.60 vs −0.51, FDR 0.023)</a:t>
@@ -5558,7 +5556,7 @@
             <a:endParaRPr lang="en-US" sz="1700" dirty="0"/>
           </a:p>
           <a:p>
-            <a:pPr algn="l" marL="342900" indent="-342900">
+            <a:pPr marL="342900" indent="-342900">
               <a:spcAft>
                 <a:spcPts val="1600"/>
               </a:spcAft>
@@ -5568,7 +5566,7 @@
             <a:r>
               <a:rPr lang="en-US" sz="1700" dirty="0">
                 <a:solidFill>
-                  <a:schemeClr val="tx1"/>
+                  <a:srgbClr val="111111"/>
                 </a:solidFill>
               </a:rPr>
               <a:t>They carry a perfect consensus core more often  (84.5% vs 78.6%, p = 0.02)</a:t>
@@ -5654,7 +5652,7 @@
         </p:nvSpPr>
         <p:spPr>
           <a:xfrm>
-            <a:off x="502920" y="5120640"/>
+            <a:off x="502920" y="5074920"/>
             <a:ext cx="11155680" cy="548640"/>
           </a:xfrm>
           <a:prstGeom prst="rect">
@@ -5679,6 +5677,36 @@
               <a:t>Ageing gains AP-1 sites over losses 2.2 : 1. Exercise reverses it, 0.67 : 1.</a:t>
             </a:r>
             <a:endParaRPr lang="en-US" sz="1600" dirty="0"/>
+          </a:p>
+        </p:txBody>
+      </p:sp>
+      <p:sp>
+        <p:nvSpPr>
+          <p:cNvPr id="7" name="Text 0"/>
+          <p:cNvSpPr/>
+          <p:nvPr>
+            <p:ph idx="101" type="body" hasCustomPrompt="1"/>
+          </p:nvPr>
+        </p:nvSpPr>
+        <p:spPr>
+          <a:xfrm>
+            <a:off x="502920" y="1234440"/>
+            <a:ext cx="11155680" cy="5120640"/>
+          </a:xfrm>
+          <a:prstGeom prst="rect">
+            <a:avLst/>
+          </a:prstGeom>
+          <a:noFill/>
+          <a:ln/>
+        </p:spPr>
+        <p:txBody>
+          <a:bodyPr wrap="square" rtlCol="0" anchor="t"/>
+          <a:lstStyle/>
+          <a:p>
+            <a:pPr algn="l" indent="0" marL="0">
+              <a:buNone/>
+            </a:pPr>
+            <a:endParaRPr lang="en-US" sz="1700" dirty="0"/>
           </a:p>
         </p:txBody>
       </p:sp>

</xml_diff>

<commit_message>
Say on the figure what the grey reference is and what each star tests
Both were unexplained: the horizontal line and band could have been read as a
threshold, and the stars gave no test, no comparison and no alpha. A shared
TEST_KEY now states it under both multi-panel figures -- grey line and band are
the median of all Stable sites with a 95% bootstrap CI, grey dots are that
class's own matched controls, the top row tests by Mann-Whitney on all sites and
the bottom row by paired Wilcoxon on matched pairs, BH across every test drawn,
with the star thresholds spelled out.

Co-Authored-By: Claude Opus 5 <noreply@anthropic.com>
</commit_message>
<xml_diff>
--- a/Analysis/AP1_AlphaGenome_results.pptx
+++ b/Analysis/AP1_AlphaGenome_results.pptx
@@ -119,18 +119,18 @@
   <p:extLst>
     <p:ext uri="{521415D9-36F7-43E2-AB2F-B90AF26B5E84}">
       <p14:sectionLst xmlns:p14="http://schemas.microsoft.com/office/powerpoint/2010/main">
-        <p14:section name="Opening" id="{9054d2d5-d101-1685-8504-eccc43d877ca}">
+        <p14:section name="Opening" id="{2bda546c-cb59-4011-5de4-a77b9aaf8a87}">
           <p14:sldIdLst>
             <p14:sldId id="256"/>
           </p14:sldIdLst>
         </p14:section>
-        <p14:section name="Design" id="{1cb7cac6-6dfd-b7c3-d5c6-b6ef7824197f}">
+        <p14:section name="Design" id="{fe987b89-4c3d-90fa-a170-74b99a9e9aba}">
           <p14:sldIdLst>
             <p14:sldId id="257"/>
             <p14:sldId id="258"/>
           </p14:sldIdLst>
         </p14:section>
-        <p14:section name="Findings" id="{b8af33d2-655d-05bf-25b7-60b92d62a64c}">
+        <p14:section name="Findings" id="{0b16b728-5e9f-5f2d-1dcb-0ee85ff4c50f}">
           <p14:sldIdLst>
             <p14:sldId id="259"/>
             <p14:sldId id="260"/>
@@ -142,7 +142,7 @@
             <p14:sldId id="266"/>
           </p14:sldIdLst>
         </p14:section>
-        <p14:section name="Conclusion" id="{65807768-0ad7-7ad6-0afd-6a7d81795a0d}">
+        <p14:section name="Conclusion" id="{d67d867a-1178-dc02-8c44-4a3b086ecb0e}">
           <p14:sldIdLst>
             <p14:sldId id="267"/>
             <p14:sldId id="268"/>
@@ -4747,8 +4747,8 @@
         </p:blipFill>
         <p:spPr>
           <a:xfrm>
-            <a:off x="882482" y="1051560"/>
-            <a:ext cx="10396556" cy="4617720"/>
+            <a:off x="657675" y="1051560"/>
+            <a:ext cx="10846171" cy="4617720"/>
           </a:xfrm>
           <a:prstGeom prst="rect">
             <a:avLst/>
@@ -5495,8 +5495,8 @@
         </p:blipFill>
         <p:spPr>
           <a:xfrm>
-            <a:off x="896167" y="1051560"/>
-            <a:ext cx="10369185" cy="4617720"/>
+            <a:off x="735892" y="1051560"/>
+            <a:ext cx="10689736" cy="4617720"/>
           </a:xfrm>
           <a:prstGeom prst="rect">
             <a:avLst/>

</xml_diff>

<commit_message>
Titration slide: keep copy number and position, drop the core-damage panels
The one-base and all-seven-base results say the same thing as the motif shuffle
already shown on the matched-null slide, so they are cut rather than repeated.
What is left is the part that slide does not cover: what a second copy is worth
and where, and how much a relocated motif recovers. The left column now shows
both position curves per class instead of the dose curve, and the class grid is
two measures wide. Numbers that are no longer plotted (one base costs -0.45 of
the -0.56 total, dose slope vs core quality rho 0.30, orientation irrelevant)
move into the speaker notes.

Co-Authored-By: Claude Opus 5 <noreply@anthropic.com>
</commit_message>
<xml_diff>
--- a/Analysis/AP1_AlphaGenome_results.pptx
+++ b/Analysis/AP1_AlphaGenome_results.pptx
@@ -120,18 +120,18 @@
   <p:extLst>
     <p:ext uri="{521415D9-36F7-43E2-AB2F-B90AF26B5E84}">
       <p14:sectionLst xmlns:p14="http://schemas.microsoft.com/office/powerpoint/2010/main">
-        <p14:section name="Opening" id="{9828b441-2f2f-c7b3-610c-50ceb5423075}">
+        <p14:section name="Opening" id="{92abd594-245a-463d-cd41-341592016d74}">
           <p14:sldIdLst>
             <p14:sldId id="256"/>
           </p14:sldIdLst>
         </p14:section>
-        <p14:section name="Design" id="{c3967755-fcb0-39e5-aa69-e82e2ba3e3a1}">
+        <p14:section name="Design" id="{5c2093be-d6b4-0c66-b714-fbd22f3e45ff}">
           <p14:sldIdLst>
             <p14:sldId id="257"/>
             <p14:sldId id="258"/>
           </p14:sldIdLst>
         </p14:section>
-        <p14:section name="Findings" id="{c49a37c9-7616-8758-b3dd-5c3c18301831}">
+        <p14:section name="Findings" id="{e636c28f-c5a8-6903-8fd0-0c68ed002e0a}">
           <p14:sldIdLst>
             <p14:sldId id="259"/>
             <p14:sldId id="260"/>
@@ -144,7 +144,7 @@
             <p14:sldId id="267"/>
           </p14:sldIdLst>
         </p14:section>
-        <p14:section name="Conclusion" id="{199aa5b4-fc81-7375-4d65-010333400a35}">
+        <p14:section name="Conclusion" id="{74930897-9547-5649-6038-27796074696c}">
           <p14:sldIdLst>
             <p14:sldId id="268"/>
             <p14:sldId id="269"/>
@@ -642,7 +642,7 @@
           <a:p>
             <a:r>
               <a:rPr lang="en-US" dirty="0"/>
-              <a:t>The dose-response slope tracks core quality measured independently from the genome sequence, rho 0.30. Orientation is irrelevant, as expected for a near-palindrome.</a:t>
+              <a:t>The 1-base and 7-base core results are not repeated here: they say the same thing as the motif shuffle on the earlier slide. One wrong base costs -0.45 of the -0.56 total, the dose slope tracks core quality read from the genome at rho 0.30, and orientation is irrelevant as expected for a near-palindrome.</a:t>
             </a:r>
             <a:endParaRPr lang="en-US" dirty="0"/>
           </a:p>
@@ -2750,7 +2750,7 @@
                   <a:schemeClr val="tx1"/>
                 </a:solidFill>
               </a:rPr>
-              <a:t>Motif strength is a switch; position is a dial</a:t>
+              <a:t>Position is a dial, and a moved motif never replaces the original</a:t>
             </a:r>
             <a:endParaRPr lang="en-US" sz="2800" dirty="0"/>
           </a:p>
@@ -2758,14 +2758,14 @@
       </p:sp>
       <p:sp>
         <p:nvSpPr>
-          <p:cNvPr id="3" name="dose-title"/>
+          <p:cNvPr id="3" name="copy-title"/>
           <p:cNvSpPr txBox="1"/>
           <p:nvPr/>
         </p:nvSpPr>
         <p:spPr>
           <a:xfrm>
             <a:off x="502920" y="1024128"/>
-            <a:ext cx="2377440" cy="274320"/>
+            <a:ext cx="2834640" cy="274320"/>
           </a:xfrm>
           <a:prstGeom prst="rect">
             <a:avLst/>
@@ -2786,7 +2786,7 @@
                   <a:srgbClr val="111111"/>
                 </a:solidFill>
               </a:rPr>
-              <a:t>The dose curve, class by class</a:t>
+              <a:t>Where the added copy works best</a:t>
             </a:r>
             <a:endParaRPr lang="en-US" sz="1250" dirty="0"/>
           </a:p>
@@ -2794,7 +2794,7 @@
       </p:sp>
       <p:pic>
         <p:nvPicPr>
-          <p:cNvPr id="4" name="Image 0" descr="/Users/z5162865/WongLab/AlphaGenome_Ap1/Analysis/slide_figures/panels/d_dose.png">    </p:cNvPr>
+          <p:cNvPr id="4" name="Image 0" descr="/Users/z5162865/WongLab/AlphaGenome_Ap1/Analysis/slide_figures/panels/d_addcopy.png">    </p:cNvPr>
           <p:cNvPicPr>
             <a:picLocks noChangeAspect="1"/>
           </p:cNvPicPr>
@@ -2808,8 +2808,8 @@
         </p:blipFill>
         <p:spPr>
           <a:xfrm>
-            <a:off x="502920" y="1330936"/>
-            <a:ext cx="2286000" cy="1681529"/>
+            <a:off x="709758" y="1325880"/>
+            <a:ext cx="2420965" cy="1783080"/>
           </a:xfrm>
           <a:prstGeom prst="rect">
             <a:avLst/>
@@ -2818,14 +2818,14 @@
       </p:pic>
       <p:sp>
         <p:nvSpPr>
-          <p:cNvPr id="5" name="copy-title"/>
+          <p:cNvPr id="5" name="move-title"/>
           <p:cNvSpPr txBox="1"/>
           <p:nvPr/>
         </p:nvSpPr>
         <p:spPr>
           <a:xfrm>
-            <a:off x="502920" y="3127248"/>
-            <a:ext cx="2377440" cy="274320"/>
+            <a:off x="502920" y="3218688"/>
+            <a:ext cx="2834640" cy="274320"/>
           </a:xfrm>
           <a:prstGeom prst="rect">
             <a:avLst/>
@@ -2846,7 +2846,7 @@
                   <a:srgbClr val="111111"/>
                 </a:solidFill>
               </a:rPr>
-              <a:t>Where a second copy helps</a:t>
+              <a:t>...and where it lands when moved</a:t>
             </a:r>
             <a:endParaRPr lang="en-US" sz="1250" dirty="0"/>
           </a:p>
@@ -2854,7 +2854,7 @@
       </p:sp>
       <p:pic>
         <p:nvPicPr>
-          <p:cNvPr id="6" name="Image 1" descr="/Users/z5162865/WongLab/AlphaGenome_Ap1/Analysis/slide_figures/panels/d_addcopy.png">    </p:cNvPr>
+          <p:cNvPr id="6" name="Image 1" descr="/Users/z5162865/WongLab/AlphaGenome_Ap1/Analysis/slide_figures/panels/d_relocate.png">    </p:cNvPr>
           <p:cNvPicPr>
             <a:picLocks noChangeAspect="1"/>
           </p:cNvPicPr>
@@ -2868,8 +2868,8 @@
         </p:blipFill>
         <p:spPr>
           <a:xfrm>
-            <a:off x="544696" y="3429000"/>
-            <a:ext cx="2202449" cy="1691640"/>
+            <a:off x="662666" y="3520440"/>
+            <a:ext cx="2515149" cy="1783080"/>
           </a:xfrm>
           <a:prstGeom prst="rect">
             <a:avLst/>
@@ -2884,8 +2884,8 @@
         </p:nvSpPr>
         <p:spPr>
           <a:xfrm>
-            <a:off x="502920" y="5166360"/>
-            <a:ext cx="2468880" cy="457200"/>
+            <a:off x="502920" y="5349240"/>
+            <a:ext cx="2926080" cy="457200"/>
           </a:xfrm>
           <a:prstGeom prst="rect">
             <a:avLst/>
@@ -2920,8 +2920,8 @@
         </p:nvSpPr>
         <p:spPr>
           <a:xfrm>
-            <a:off x="3995928" y="1005840"/>
-            <a:ext cx="1842516" cy="438912"/>
+            <a:off x="4681728" y="1005840"/>
+            <a:ext cx="3438144" cy="438912"/>
           </a:xfrm>
           <a:prstGeom prst="rect">
             <a:avLst/>
@@ -2942,7 +2942,7 @@
                   <a:srgbClr val="111111"/>
                 </a:solidFill>
               </a:rPr>
-              <a:t>One damaged core base</a:t>
+              <a:t>A second copy added</a:t>
             </a:r>
             <a:endParaRPr lang="en-US" sz="1250" dirty="0"/>
           </a:p>
@@ -2956,8 +2956,8 @@
         </p:nvSpPr>
         <p:spPr>
           <a:xfrm>
-            <a:off x="3995928" y="1435608"/>
-            <a:ext cx="1842516" cy="310896"/>
+            <a:off x="4681728" y="1435608"/>
+            <a:ext cx="3438144" cy="310896"/>
           </a:xfrm>
           <a:prstGeom prst="rect">
             <a:avLst/>
@@ -2978,7 +2978,7 @@
                   <a:srgbClr val="595959"/>
                 </a:solidFill>
               </a:rPr>
-              <a:t>TGACTCA with a single base changed</a:t>
+              <a:t>net of a shuffled-sequence control</a:t>
             </a:r>
             <a:endParaRPr lang="en-US" sz="950" dirty="0"/>
           </a:p>
@@ -3000,8 +3000,8 @@
         </p:blipFill>
         <p:spPr>
           <a:xfrm>
-            <a:off x="3995928" y="1902045"/>
-            <a:ext cx="1842516" cy="1170247"/>
+            <a:off x="5249045" y="1755648"/>
+            <a:ext cx="2303510" cy="1463040"/>
           </a:xfrm>
           <a:prstGeom prst="rect">
             <a:avLst/>
@@ -3024,8 +3024,8 @@
         </p:blipFill>
         <p:spPr>
           <a:xfrm>
-            <a:off x="3995928" y="3438237"/>
-            <a:ext cx="1842516" cy="1170247"/>
+            <a:off x="5249045" y="3291840"/>
+            <a:ext cx="2303510" cy="1463040"/>
           </a:xfrm>
           <a:prstGeom prst="rect">
             <a:avLst/>
@@ -3040,8 +3040,8 @@
         </p:nvSpPr>
         <p:spPr>
           <a:xfrm>
-            <a:off x="5911596" y="1005840"/>
-            <a:ext cx="1842516" cy="438912"/>
+            <a:off x="8193024" y="1005840"/>
+            <a:ext cx="3438144" cy="438912"/>
           </a:xfrm>
           <a:prstGeom prst="rect">
             <a:avLst/>
@@ -3062,7 +3062,7 @@
                   <a:srgbClr val="111111"/>
                 </a:solidFill>
               </a:rPr>
-              <a:t>All seven core bases</a:t>
+              <a:t>The motif moved elsewhere</a:t>
             </a:r>
             <a:endParaRPr lang="en-US" sz="1250" dirty="0"/>
           </a:p>
@@ -3076,8 +3076,8 @@
         </p:nvSpPr>
         <p:spPr>
           <a:xfrm>
-            <a:off x="5911596" y="1435608"/>
-            <a:ext cx="1842516" cy="310896"/>
+            <a:off x="8193024" y="1435608"/>
+            <a:ext cx="3438144" cy="310896"/>
           </a:xfrm>
           <a:prstGeom prst="rect">
             <a:avLst/>
@@ -3098,7 +3098,7 @@
                   <a:srgbClr val="595959"/>
                 </a:solidFill>
               </a:rPr>
-              <a:t>the motif destroyed outright</a:t>
+              <a:t>the motif destroyed and re-inserted, net of the same control</a:t>
             </a:r>
             <a:endParaRPr lang="en-US" sz="950" dirty="0"/>
           </a:p>
@@ -3120,8 +3120,8 @@
         </p:blipFill>
         <p:spPr>
           <a:xfrm>
-            <a:off x="5911596" y="1902045"/>
-            <a:ext cx="1842516" cy="1170247"/>
+            <a:off x="8760341" y="1755648"/>
+            <a:ext cx="2303510" cy="1463040"/>
           </a:xfrm>
           <a:prstGeom prst="rect">
             <a:avLst/>
@@ -3144,8 +3144,8 @@
         </p:blipFill>
         <p:spPr>
           <a:xfrm>
-            <a:off x="5911596" y="3438237"/>
-            <a:ext cx="1842516" cy="1170247"/>
+            <a:off x="8760341" y="3291840"/>
+            <a:ext cx="2303510" cy="1463040"/>
           </a:xfrm>
           <a:prstGeom prst="rect">
             <a:avLst/>
@@ -3154,275 +3154,71 @@
       </p:pic>
       <p:sp>
         <p:nvSpPr>
-          <p:cNvPr id="16" name="s4_titration-title-2"/>
+          <p:cNvPr id="16" name="s4_titration-row-0"/>
           <p:cNvSpPr txBox="1"/>
           <p:nvPr/>
         </p:nvSpPr>
         <p:spPr>
-          <a:xfrm>
-            <a:off x="7827264" y="1005840"/>
-            <a:ext cx="1842516" cy="438912"/>
-          </a:xfrm>
-          <a:prstGeom prst="rect">
-            <a:avLst/>
-          </a:prstGeom>
-          <a:noFill/>
-          <a:ln/>
-        </p:spPr>
-        <p:txBody>
-          <a:bodyPr wrap="square" lIns="0" tIns="0" rIns="0" bIns="0" rtlCol="0" anchor="t"/>
-          <a:lstStyle/>
-          <a:p>
-            <a:pPr indent="0" marL="0">
-              <a:buNone/>
-            </a:pPr>
-            <a:r>
-              <a:rPr lang="en-US" sz="1250" b="1" dirty="0">
+          <a:xfrm rot="16200000">
+            <a:off x="3639312" y="1837944"/>
+            <a:ext cx="1371600" cy="1371600"/>
+          </a:xfrm>
+          <a:prstGeom prst="rect">
+            <a:avLst/>
+          </a:prstGeom>
+          <a:noFill/>
+          <a:ln/>
+        </p:spPr>
+        <p:txBody>
+          <a:bodyPr wrap="square" lIns="0" tIns="0" rIns="0" bIns="0" rtlCol="0" anchor="ctr"/>
+          <a:lstStyle/>
+          <a:p>
+            <a:pPr algn="ctr" indent="0" marL="0">
+              <a:buNone/>
+            </a:pPr>
+            <a:r>
+              <a:rPr lang="en-US" sz="1000" dirty="0">
                 <a:solidFill>
                   <a:srgbClr val="111111"/>
                 </a:solidFill>
               </a:rPr>
-              <a:t>A second copy added</a:t>
-            </a:r>
-            <a:endParaRPr lang="en-US" sz="1250" dirty="0"/>
-          </a:p>
-        </p:txBody>
-      </p:sp>
-      <p:sp>
-        <p:nvSpPr>
-          <p:cNvPr id="17" name="s4_titration-sub-2"/>
+              <a:t>all sites, nothing controlled</a:t>
+            </a:r>
+            <a:endParaRPr lang="en-US" sz="1000" dirty="0"/>
+          </a:p>
+        </p:txBody>
+      </p:sp>
+      <p:sp>
+        <p:nvSpPr>
+          <p:cNvPr id="17" name="s4_titration-row-1"/>
           <p:cNvSpPr txBox="1"/>
           <p:nvPr/>
         </p:nvSpPr>
         <p:spPr>
-          <a:xfrm>
-            <a:off x="7827264" y="1435608"/>
-            <a:ext cx="1842516" cy="310896"/>
-          </a:xfrm>
-          <a:prstGeom prst="rect">
-            <a:avLst/>
-          </a:prstGeom>
-          <a:noFill/>
-          <a:ln/>
-        </p:spPr>
-        <p:txBody>
-          <a:bodyPr wrap="square" lIns="0" tIns="0" rIns="0" bIns="0" rtlCol="0" anchor="t"/>
-          <a:lstStyle/>
-          <a:p>
-            <a:pPr indent="0" marL="0">
-              <a:buNone/>
-            </a:pPr>
-            <a:r>
-              <a:rPr lang="en-US" sz="950" dirty="0">
-                <a:solidFill>
-                  <a:srgbClr val="595959"/>
-                </a:solidFill>
-              </a:rPr>
-              <a:t>net of a shuffled-sequence control</a:t>
-            </a:r>
-            <a:endParaRPr lang="en-US" sz="950" dirty="0"/>
-          </a:p>
-        </p:txBody>
-      </p:sp>
-      <p:pic>
-        <p:nvPicPr>
-          <p:cNvPr id="18" name="Image 6" descr="/Users/z5162865/WongLab/AlphaGenome_Ap1/Analysis/slide_figures/panels/s4_titration_c2_r0.png">    </p:cNvPr>
-          <p:cNvPicPr>
-            <a:picLocks noChangeAspect="1"/>
-          </p:cNvPicPr>
-          <p:nvPr/>
-        </p:nvPicPr>
-        <p:blipFill>
-          <a:blip r:embed="rId7"/>
-          <a:stretch>
-            <a:fillRect/>
-          </a:stretch>
-        </p:blipFill>
-        <p:spPr>
-          <a:xfrm>
-            <a:off x="7827264" y="1902045"/>
-            <a:ext cx="1842516" cy="1170247"/>
-          </a:xfrm>
-          <a:prstGeom prst="rect">
-            <a:avLst/>
-          </a:prstGeom>
-        </p:spPr>
-      </p:pic>
-      <p:pic>
-        <p:nvPicPr>
-          <p:cNvPr id="19" name="Image 7" descr="/Users/z5162865/WongLab/AlphaGenome_Ap1/Analysis/slide_figures/panels/s4_titration_c2_r1.png">    </p:cNvPr>
-          <p:cNvPicPr>
-            <a:picLocks noChangeAspect="1"/>
-          </p:cNvPicPr>
-          <p:nvPr/>
-        </p:nvPicPr>
-        <p:blipFill>
-          <a:blip r:embed="rId8"/>
-          <a:stretch>
-            <a:fillRect/>
-          </a:stretch>
-        </p:blipFill>
-        <p:spPr>
-          <a:xfrm>
-            <a:off x="7827264" y="3438237"/>
-            <a:ext cx="1842516" cy="1170247"/>
-          </a:xfrm>
-          <a:prstGeom prst="rect">
-            <a:avLst/>
-          </a:prstGeom>
-        </p:spPr>
-      </p:pic>
-      <p:sp>
-        <p:nvSpPr>
-          <p:cNvPr id="20" name="s4_titration-title-3"/>
-          <p:cNvSpPr txBox="1"/>
-          <p:nvPr/>
-        </p:nvSpPr>
-        <p:spPr>
-          <a:xfrm>
-            <a:off x="9742932" y="1005840"/>
-            <a:ext cx="1842516" cy="438912"/>
-          </a:xfrm>
-          <a:prstGeom prst="rect">
-            <a:avLst/>
-          </a:prstGeom>
-          <a:noFill/>
-          <a:ln/>
-        </p:spPr>
-        <p:txBody>
-          <a:bodyPr wrap="square" lIns="0" tIns="0" rIns="0" bIns="0" rtlCol="0" anchor="t"/>
-          <a:lstStyle/>
-          <a:p>
-            <a:pPr indent="0" marL="0">
-              <a:buNone/>
-            </a:pPr>
-            <a:r>
-              <a:rPr lang="en-US" sz="1250" b="1" dirty="0">
+          <a:xfrm rot="16200000">
+            <a:off x="3639312" y="3374136"/>
+            <a:ext cx="1371600" cy="1371600"/>
+          </a:xfrm>
+          <a:prstGeom prst="rect">
+            <a:avLst/>
+          </a:prstGeom>
+          <a:noFill/>
+          <a:ln/>
+        </p:spPr>
+        <p:txBody>
+          <a:bodyPr wrap="square" lIns="0" tIns="0" rIns="0" bIns="0" rtlCol="0" anchor="ctr"/>
+          <a:lstStyle/>
+          <a:p>
+            <a:pPr algn="ctr" indent="0" marL="0">
+              <a:buNone/>
+            </a:pPr>
+            <a:r>
+              <a:rPr lang="en-US" sz="1000" dirty="0">
                 <a:solidFill>
                   <a:srgbClr val="111111"/>
                 </a:solidFill>
               </a:rPr>
-              <a:t>The motif moved elsewhere</a:t>
-            </a:r>
-            <a:endParaRPr lang="en-US" sz="1250" dirty="0"/>
-          </a:p>
-        </p:txBody>
-      </p:sp>
-      <p:sp>
-        <p:nvSpPr>
-          <p:cNvPr id="21" name="s4_titration-sub-3"/>
-          <p:cNvSpPr txBox="1"/>
-          <p:nvPr/>
-        </p:nvSpPr>
-        <p:spPr>
-          <a:xfrm>
-            <a:off x="9742932" y="1435608"/>
-            <a:ext cx="1842516" cy="310896"/>
-          </a:xfrm>
-          <a:prstGeom prst="rect">
-            <a:avLst/>
-          </a:prstGeom>
-          <a:noFill/>
-          <a:ln/>
-        </p:spPr>
-        <p:txBody>
-          <a:bodyPr wrap="square" lIns="0" tIns="0" rIns="0" bIns="0" rtlCol="0" anchor="t"/>
-          <a:lstStyle/>
-          <a:p>
-            <a:pPr indent="0" marL="0">
-              <a:buNone/>
-            </a:pPr>
-            <a:r>
-              <a:rPr lang="en-US" sz="950" dirty="0">
-                <a:solidFill>
-                  <a:srgbClr val="595959"/>
-                </a:solidFill>
-              </a:rPr>
-              <a:t>net of the same control</a:t>
-            </a:r>
-            <a:endParaRPr lang="en-US" sz="950" dirty="0"/>
-          </a:p>
-        </p:txBody>
-      </p:sp>
-      <p:pic>
-        <p:nvPicPr>
-          <p:cNvPr id="22" name="Image 8" descr="/Users/z5162865/WongLab/AlphaGenome_Ap1/Analysis/slide_figures/panels/s4_titration_c3_r0.png">    </p:cNvPr>
-          <p:cNvPicPr>
-            <a:picLocks noChangeAspect="1"/>
-          </p:cNvPicPr>
-          <p:nvPr/>
-        </p:nvPicPr>
-        <p:blipFill>
-          <a:blip r:embed="rId9"/>
-          <a:stretch>
-            <a:fillRect/>
-          </a:stretch>
-        </p:blipFill>
-        <p:spPr>
-          <a:xfrm>
-            <a:off x="9742932" y="1902045"/>
-            <a:ext cx="1842516" cy="1170247"/>
-          </a:xfrm>
-          <a:prstGeom prst="rect">
-            <a:avLst/>
-          </a:prstGeom>
-        </p:spPr>
-      </p:pic>
-      <p:pic>
-        <p:nvPicPr>
-          <p:cNvPr id="23" name="Image 9" descr="/Users/z5162865/WongLab/AlphaGenome_Ap1/Analysis/slide_figures/panels/s4_titration_c3_r1.png">    </p:cNvPr>
-          <p:cNvPicPr>
-            <a:picLocks noChangeAspect="1"/>
-          </p:cNvPicPr>
-          <p:nvPr/>
-        </p:nvPicPr>
-        <p:blipFill>
-          <a:blip r:embed="rId10"/>
-          <a:stretch>
-            <a:fillRect/>
-          </a:stretch>
-        </p:blipFill>
-        <p:spPr>
-          <a:xfrm>
-            <a:off x="9742932" y="3438237"/>
-            <a:ext cx="1842516" cy="1170247"/>
-          </a:xfrm>
-          <a:prstGeom prst="rect">
-            <a:avLst/>
-          </a:prstGeom>
-        </p:spPr>
-      </p:pic>
-      <p:sp>
-        <p:nvSpPr>
-          <p:cNvPr id="24" name="s4_titration-row-0"/>
-          <p:cNvSpPr txBox="1"/>
-          <p:nvPr/>
-        </p:nvSpPr>
-        <p:spPr>
-          <a:xfrm rot="16200000">
-            <a:off x="2953512" y="1837944"/>
-            <a:ext cx="1371600" cy="1371600"/>
-          </a:xfrm>
-          <a:prstGeom prst="rect">
-            <a:avLst/>
-          </a:prstGeom>
-          <a:noFill/>
-          <a:ln/>
-        </p:spPr>
-        <p:txBody>
-          <a:bodyPr wrap="square" lIns="0" tIns="0" rIns="0" bIns="0" rtlCol="0" anchor="ctr"/>
-          <a:lstStyle/>
-          <a:p>
-            <a:pPr algn="ctr" indent="0" marL="0">
-              <a:buNone/>
-            </a:pPr>
-            <a:r>
-              <a:rPr lang="en-US" sz="1000" dirty="0">
-                <a:solidFill>
-                  <a:srgbClr val="111111"/>
-                </a:solidFill>
-              </a:rPr>
-              <a:t>all sites, nothing controlled</a:t>
+              <a:t>each class against its own matched Stable controls</a:t>
             </a:r>
             <a:endParaRPr lang="en-US" sz="1000" dirty="0"/>
           </a:p>
@@ -3430,49 +3226,13 @@
       </p:sp>
       <p:sp>
         <p:nvSpPr>
-          <p:cNvPr id="25" name="s4_titration-row-1"/>
-          <p:cNvSpPr txBox="1"/>
-          <p:nvPr/>
-        </p:nvSpPr>
-        <p:spPr>
-          <a:xfrm rot="16200000">
-            <a:off x="2953512" y="3374136"/>
-            <a:ext cx="1371600" cy="1371600"/>
-          </a:xfrm>
-          <a:prstGeom prst="rect">
-            <a:avLst/>
-          </a:prstGeom>
-          <a:noFill/>
-          <a:ln/>
-        </p:spPr>
-        <p:txBody>
-          <a:bodyPr wrap="square" lIns="0" tIns="0" rIns="0" bIns="0" rtlCol="0" anchor="ctr"/>
-          <a:lstStyle/>
-          <a:p>
-            <a:pPr algn="ctr" indent="0" marL="0">
-              <a:buNone/>
-            </a:pPr>
-            <a:r>
-              <a:rPr lang="en-US" sz="1000" dirty="0">
-                <a:solidFill>
-                  <a:srgbClr val="111111"/>
-                </a:solidFill>
-              </a:rPr>
-              <a:t>each class against its own matched Stable controls</a:t>
-            </a:r>
-            <a:endParaRPr lang="en-US" sz="1000" dirty="0"/>
-          </a:p>
-        </p:txBody>
-      </p:sp>
-      <p:sp>
-        <p:nvSpPr>
-          <p:cNvPr id="26" name="s4_titration-dot-0"/>
+          <p:cNvPr id="18" name="s4_titration-dot-0"/>
           <p:cNvSpPr/>
           <p:nvPr/>
         </p:nvSpPr>
         <p:spPr>
           <a:xfrm>
-            <a:off x="3995928" y="4960620"/>
+            <a:off x="4114800" y="4960620"/>
             <a:ext cx="109728" cy="109728"/>
           </a:xfrm>
           <a:prstGeom prst="ellipse">
@@ -3491,13 +3251,13 @@
       </p:sp>
       <p:sp>
         <p:nvSpPr>
-          <p:cNvPr id="27" name="s4_titration-leg-0"/>
+          <p:cNvPr id="19" name="s4_titration-leg-0"/>
           <p:cNvSpPr txBox="1"/>
           <p:nvPr/>
         </p:nvSpPr>
         <p:spPr>
           <a:xfrm>
-            <a:off x="4151376" y="4919472"/>
+            <a:off x="4270248" y="4919472"/>
             <a:ext cx="1057046" cy="201168"/>
           </a:xfrm>
           <a:prstGeom prst="rect">
@@ -3527,13 +3287,13 @@
       </p:sp>
       <p:sp>
         <p:nvSpPr>
-          <p:cNvPr id="28" name="s4_titration-dot-1"/>
+          <p:cNvPr id="20" name="s4_titration-dot-1"/>
           <p:cNvSpPr/>
           <p:nvPr/>
         </p:nvSpPr>
         <p:spPr>
           <a:xfrm>
-            <a:off x="5318150" y="4960620"/>
+            <a:off x="5437022" y="4960620"/>
             <a:ext cx="109728" cy="109728"/>
           </a:xfrm>
           <a:prstGeom prst="ellipse">
@@ -3552,13 +3312,13 @@
       </p:sp>
       <p:sp>
         <p:nvSpPr>
-          <p:cNvPr id="29" name="s4_titration-leg-1"/>
+          <p:cNvPr id="21" name="s4_titration-leg-1"/>
           <p:cNvSpPr txBox="1"/>
           <p:nvPr/>
         </p:nvSpPr>
         <p:spPr>
           <a:xfrm>
-            <a:off x="5473598" y="4919472"/>
+            <a:off x="5592470" y="4919472"/>
             <a:ext cx="596189" cy="201168"/>
           </a:xfrm>
           <a:prstGeom prst="rect">
@@ -3588,13 +3348,13 @@
       </p:sp>
       <p:sp>
         <p:nvSpPr>
-          <p:cNvPr id="30" name="s4_titration-dot-2"/>
+          <p:cNvPr id="22" name="s4_titration-dot-2"/>
           <p:cNvSpPr/>
           <p:nvPr/>
         </p:nvSpPr>
         <p:spPr>
           <a:xfrm>
-            <a:off x="6179515" y="4960620"/>
+            <a:off x="6298387" y="4960620"/>
             <a:ext cx="109728" cy="109728"/>
           </a:xfrm>
           <a:prstGeom prst="ellipse">
@@ -3613,13 +3373,13 @@
       </p:sp>
       <p:sp>
         <p:nvSpPr>
-          <p:cNvPr id="31" name="s4_titration-leg-2"/>
+          <p:cNvPr id="23" name="s4_titration-leg-2"/>
           <p:cNvSpPr txBox="1"/>
           <p:nvPr/>
         </p:nvSpPr>
         <p:spPr>
           <a:xfrm>
-            <a:off x="6334963" y="4919472"/>
+            <a:off x="6453835" y="4919472"/>
             <a:ext cx="727862" cy="201168"/>
           </a:xfrm>
           <a:prstGeom prst="rect">
@@ -3649,13 +3409,13 @@
       </p:sp>
       <p:sp>
         <p:nvSpPr>
-          <p:cNvPr id="32" name="s4_titration-dot-3"/>
+          <p:cNvPr id="24" name="s4_titration-dot-3"/>
           <p:cNvSpPr/>
           <p:nvPr/>
         </p:nvSpPr>
         <p:spPr>
           <a:xfrm>
-            <a:off x="7172554" y="4960620"/>
+            <a:off x="7291426" y="4960620"/>
             <a:ext cx="109728" cy="109728"/>
           </a:xfrm>
           <a:prstGeom prst="ellipse">
@@ -3674,13 +3434,13 @@
       </p:sp>
       <p:sp>
         <p:nvSpPr>
-          <p:cNvPr id="33" name="s4_titration-leg-3"/>
+          <p:cNvPr id="25" name="s4_titration-leg-3"/>
           <p:cNvSpPr txBox="1"/>
           <p:nvPr/>
         </p:nvSpPr>
         <p:spPr>
           <a:xfrm>
-            <a:off x="7328002" y="4919472"/>
+            <a:off x="7446874" y="4919472"/>
             <a:ext cx="925373" cy="201168"/>
           </a:xfrm>
           <a:prstGeom prst="rect">
@@ -3710,13 +3470,13 @@
       </p:sp>
       <p:sp>
         <p:nvSpPr>
-          <p:cNvPr id="34" name="s4_titration-dot-4"/>
+          <p:cNvPr id="26" name="s4_titration-dot-4"/>
           <p:cNvSpPr/>
           <p:nvPr/>
         </p:nvSpPr>
         <p:spPr>
           <a:xfrm>
-            <a:off x="8363102" y="4960620"/>
+            <a:off x="8481974" y="4960620"/>
             <a:ext cx="109728" cy="109728"/>
           </a:xfrm>
           <a:prstGeom prst="ellipse">
@@ -3735,13 +3495,13 @@
       </p:sp>
       <p:sp>
         <p:nvSpPr>
-          <p:cNvPr id="35" name="s4_titration-leg-4"/>
+          <p:cNvPr id="27" name="s4_titration-leg-4"/>
           <p:cNvSpPr txBox="1"/>
           <p:nvPr/>
         </p:nvSpPr>
         <p:spPr>
           <a:xfrm>
-            <a:off x="8518550" y="4919472"/>
+            <a:off x="8637422" y="4919472"/>
             <a:ext cx="1057046" cy="201168"/>
           </a:xfrm>
           <a:prstGeom prst="rect">
@@ -3771,13 +3531,13 @@
       </p:sp>
       <p:sp>
         <p:nvSpPr>
-          <p:cNvPr id="36" name="s4_titration-dot-5"/>
+          <p:cNvPr id="28" name="s4_titration-dot-5"/>
           <p:cNvSpPr/>
           <p:nvPr/>
         </p:nvSpPr>
         <p:spPr>
           <a:xfrm>
-            <a:off x="9685325" y="4960620"/>
+            <a:off x="9804197" y="4960620"/>
             <a:ext cx="109728" cy="109728"/>
           </a:xfrm>
           <a:prstGeom prst="ellipse">
@@ -3796,13 +3556,13 @@
       </p:sp>
       <p:sp>
         <p:nvSpPr>
-          <p:cNvPr id="37" name="s4_titration-leg-5"/>
+          <p:cNvPr id="29" name="s4_titration-leg-5"/>
           <p:cNvSpPr txBox="1"/>
           <p:nvPr/>
         </p:nvSpPr>
         <p:spPr>
           <a:xfrm>
-            <a:off x="9840773" y="4919472"/>
+            <a:off x="9959645" y="4919472"/>
             <a:ext cx="2373782" cy="201168"/>
           </a:xfrm>
           <a:prstGeom prst="rect">
@@ -3832,14 +3592,14 @@
       </p:sp>
       <p:sp>
         <p:nvSpPr>
-          <p:cNvPr id="38" name="s4_titration-key"/>
+          <p:cNvPr id="30" name="s4_titration-key"/>
           <p:cNvSpPr txBox="1"/>
           <p:nvPr/>
         </p:nvSpPr>
         <p:spPr>
           <a:xfrm>
-            <a:off x="3429000" y="5193792"/>
-            <a:ext cx="8229600" cy="502920"/>
+            <a:off x="4114800" y="5193792"/>
+            <a:ext cx="7589520" cy="502920"/>
           </a:xfrm>
           <a:prstGeom prst="rect">
             <a:avLst/>
@@ -3860,7 +3620,7 @@
                   <a:srgbClr val="595959"/>
                 </a:solidFill>
               </a:rPr>
-              <a:t>grey line and band (top row): all Stable sites, median with 95% bootstrap CI.   grey dots (bottom row): that class's own matched Stable controls.   Stars test the class against that reference — Mann–Whitney on all sites, paired Wilcoxon on matched pairs — BH across all 40 tests.   *** p&lt;0.001   ** p&lt;0.01   * p&lt;0.05   ns ≥ 0.05</a:t>
+              <a:t>grey line and band (top row): all Stable sites, median with 95% bootstrap CI.   grey dots (bottom row): that class's own matched Stable controls.   Stars test the class against that reference — Mann–Whitney on all sites, paired Wilcoxon on matched pairs — BH across all 20 tests.   *** p&lt;0.001   ** p&lt;0.01   * p&lt;0.05   ns ≥ 0.05</a:t>
             </a:r>
             <a:endParaRPr lang="en-US" sz="900" dirty="0"/>
           </a:p>
@@ -3868,7 +3628,7 @@
       </p:sp>
       <p:sp>
         <p:nvSpPr>
-          <p:cNvPr id="39" name="Text 0"/>
+          <p:cNvPr id="31" name="Text 0"/>
           <p:cNvSpPr/>
           <p:nvPr>
             <p:ph idx="101" type="body" hasCustomPrompt="1"/>
@@ -3909,7 +3669,7 @@
                   <a:srgbClr val="111111"/>
                 </a:solidFill>
               </a:rPr>
-              <a:t>one wrong base costs −0.45 of the −0.56 total and a moved motif recovers only a third — but every class titrates the same way</a:t>
+              <a:t>a second copy is worth most at ±20–40 bp and a moved motif recovers only a third of what destroying it cost — and no class differs once context is matched</a:t>
             </a:r>
             <a:endParaRPr lang="en-US" sz="1500" dirty="0"/>
           </a:p>
@@ -6974,7 +6734,7 @@
         </p:nvSpPr>
         <p:spPr>
           <a:xfrm>
-            <a:off x="1618488" y="4960620"/>
+            <a:off x="960120" y="4960620"/>
             <a:ext cx="109728" cy="109728"/>
           </a:xfrm>
           <a:prstGeom prst="ellipse">
@@ -6999,7 +6759,7 @@
         </p:nvSpPr>
         <p:spPr>
           <a:xfrm>
-            <a:off x="1773936" y="4919472"/>
+            <a:off x="1115568" y="4919472"/>
             <a:ext cx="1057046" cy="201168"/>
           </a:xfrm>
           <a:prstGeom prst="rect">
@@ -7035,7 +6795,7 @@
         </p:nvSpPr>
         <p:spPr>
           <a:xfrm>
-            <a:off x="2940710" y="4960620"/>
+            <a:off x="2282342" y="4960620"/>
             <a:ext cx="109728" cy="109728"/>
           </a:xfrm>
           <a:prstGeom prst="ellipse">
@@ -7060,7 +6820,7 @@
         </p:nvSpPr>
         <p:spPr>
           <a:xfrm>
-            <a:off x="3096158" y="4919472"/>
+            <a:off x="2437790" y="4919472"/>
             <a:ext cx="596189" cy="201168"/>
           </a:xfrm>
           <a:prstGeom prst="rect">
@@ -7096,7 +6856,7 @@
         </p:nvSpPr>
         <p:spPr>
           <a:xfrm>
-            <a:off x="3802075" y="4960620"/>
+            <a:off x="3143707" y="4960620"/>
             <a:ext cx="109728" cy="109728"/>
           </a:xfrm>
           <a:prstGeom prst="ellipse">
@@ -7121,7 +6881,7 @@
         </p:nvSpPr>
         <p:spPr>
           <a:xfrm>
-            <a:off x="3957523" y="4919472"/>
+            <a:off x="3299155" y="4919472"/>
             <a:ext cx="727862" cy="201168"/>
           </a:xfrm>
           <a:prstGeom prst="rect">
@@ -7157,7 +6917,7 @@
         </p:nvSpPr>
         <p:spPr>
           <a:xfrm>
-            <a:off x="4795114" y="4960620"/>
+            <a:off x="4136746" y="4960620"/>
             <a:ext cx="109728" cy="109728"/>
           </a:xfrm>
           <a:prstGeom prst="ellipse">
@@ -7182,7 +6942,7 @@
         </p:nvSpPr>
         <p:spPr>
           <a:xfrm>
-            <a:off x="4950562" y="4919472"/>
+            <a:off x="4292194" y="4919472"/>
             <a:ext cx="925373" cy="201168"/>
           </a:xfrm>
           <a:prstGeom prst="rect">
@@ -7218,7 +6978,7 @@
         </p:nvSpPr>
         <p:spPr>
           <a:xfrm>
-            <a:off x="5985662" y="4960620"/>
+            <a:off x="5327294" y="4960620"/>
             <a:ext cx="109728" cy="109728"/>
           </a:xfrm>
           <a:prstGeom prst="ellipse">
@@ -7243,7 +7003,7 @@
         </p:nvSpPr>
         <p:spPr>
           <a:xfrm>
-            <a:off x="6141110" y="4919472"/>
+            <a:off x="5482742" y="4919472"/>
             <a:ext cx="1057046" cy="201168"/>
           </a:xfrm>
           <a:prstGeom prst="rect">
@@ -7279,7 +7039,7 @@
         </p:nvSpPr>
         <p:spPr>
           <a:xfrm>
-            <a:off x="7307885" y="4960620"/>
+            <a:off x="6649517" y="4960620"/>
             <a:ext cx="109728" cy="109728"/>
           </a:xfrm>
           <a:prstGeom prst="ellipse">
@@ -7304,7 +7064,7 @@
         </p:nvSpPr>
         <p:spPr>
           <a:xfrm>
-            <a:off x="7463333" y="4919472"/>
+            <a:off x="6804965" y="4919472"/>
             <a:ext cx="2373782" cy="201168"/>
           </a:xfrm>
           <a:prstGeom prst="rect">
@@ -8994,7 +8754,7 @@
         </p:nvSpPr>
         <p:spPr>
           <a:xfrm>
-            <a:off x="2670048" y="4960620"/>
+            <a:off x="2011680" y="4960620"/>
             <a:ext cx="109728" cy="109728"/>
           </a:xfrm>
           <a:prstGeom prst="ellipse">
@@ -9019,7 +8779,7 @@
         </p:nvSpPr>
         <p:spPr>
           <a:xfrm>
-            <a:off x="2825496" y="4919472"/>
+            <a:off x="2167128" y="4919472"/>
             <a:ext cx="1057046" cy="201168"/>
           </a:xfrm>
           <a:prstGeom prst="rect">
@@ -9055,7 +8815,7 @@
         </p:nvSpPr>
         <p:spPr>
           <a:xfrm>
-            <a:off x="3992270" y="4960620"/>
+            <a:off x="3333902" y="4960620"/>
             <a:ext cx="109728" cy="109728"/>
           </a:xfrm>
           <a:prstGeom prst="ellipse">
@@ -9080,7 +8840,7 @@
         </p:nvSpPr>
         <p:spPr>
           <a:xfrm>
-            <a:off x="4147718" y="4919472"/>
+            <a:off x="3489350" y="4919472"/>
             <a:ext cx="596189" cy="201168"/>
           </a:xfrm>
           <a:prstGeom prst="rect">
@@ -9116,7 +8876,7 @@
         </p:nvSpPr>
         <p:spPr>
           <a:xfrm>
-            <a:off x="4853635" y="4960620"/>
+            <a:off x="4195267" y="4960620"/>
             <a:ext cx="109728" cy="109728"/>
           </a:xfrm>
           <a:prstGeom prst="ellipse">
@@ -9141,7 +8901,7 @@
         </p:nvSpPr>
         <p:spPr>
           <a:xfrm>
-            <a:off x="5009083" y="4919472"/>
+            <a:off x="4350715" y="4919472"/>
             <a:ext cx="727862" cy="201168"/>
           </a:xfrm>
           <a:prstGeom prst="rect">
@@ -9177,7 +8937,7 @@
         </p:nvSpPr>
         <p:spPr>
           <a:xfrm>
-            <a:off x="5846674" y="4960620"/>
+            <a:off x="5188306" y="4960620"/>
             <a:ext cx="109728" cy="109728"/>
           </a:xfrm>
           <a:prstGeom prst="ellipse">
@@ -9202,7 +8962,7 @@
         </p:nvSpPr>
         <p:spPr>
           <a:xfrm>
-            <a:off x="6002122" y="4919472"/>
+            <a:off x="5343754" y="4919472"/>
             <a:ext cx="925373" cy="201168"/>
           </a:xfrm>
           <a:prstGeom prst="rect">
@@ -9238,7 +8998,7 @@
         </p:nvSpPr>
         <p:spPr>
           <a:xfrm>
-            <a:off x="7037222" y="4960620"/>
+            <a:off x="6378854" y="4960620"/>
             <a:ext cx="109728" cy="109728"/>
           </a:xfrm>
           <a:prstGeom prst="ellipse">
@@ -9263,7 +9023,7 @@
         </p:nvSpPr>
         <p:spPr>
           <a:xfrm>
-            <a:off x="7192670" y="4919472"/>
+            <a:off x="6534302" y="4919472"/>
             <a:ext cx="1057046" cy="201168"/>
           </a:xfrm>
           <a:prstGeom prst="rect">
@@ -9299,7 +9059,7 @@
         </p:nvSpPr>
         <p:spPr>
           <a:xfrm>
-            <a:off x="8359445" y="4960620"/>
+            <a:off x="7701077" y="4960620"/>
             <a:ext cx="109728" cy="109728"/>
           </a:xfrm>
           <a:prstGeom prst="ellipse">
@@ -9324,7 +9084,7 @@
         </p:nvSpPr>
         <p:spPr>
           <a:xfrm>
-            <a:off x="8514893" y="4919472"/>
+            <a:off x="7856525" y="4919472"/>
             <a:ext cx="2373782" cy="201168"/>
           </a:xfrm>
           <a:prstGeom prst="rect">
@@ -10346,7 +10106,7 @@
         </p:nvSpPr>
         <p:spPr>
           <a:xfrm>
-            <a:off x="3995928" y="4960620"/>
+            <a:off x="3429000" y="4960620"/>
             <a:ext cx="109728" cy="109728"/>
           </a:xfrm>
           <a:prstGeom prst="ellipse">
@@ -10371,7 +10131,7 @@
         </p:nvSpPr>
         <p:spPr>
           <a:xfrm>
-            <a:off x="4151376" y="4919472"/>
+            <a:off x="3584448" y="4919472"/>
             <a:ext cx="1057046" cy="201168"/>
           </a:xfrm>
           <a:prstGeom prst="rect">
@@ -10407,7 +10167,7 @@
         </p:nvSpPr>
         <p:spPr>
           <a:xfrm>
-            <a:off x="5318150" y="4960620"/>
+            <a:off x="4751222" y="4960620"/>
             <a:ext cx="109728" cy="109728"/>
           </a:xfrm>
           <a:prstGeom prst="ellipse">
@@ -10432,7 +10192,7 @@
         </p:nvSpPr>
         <p:spPr>
           <a:xfrm>
-            <a:off x="5473598" y="4919472"/>
+            <a:off x="4906670" y="4919472"/>
             <a:ext cx="596189" cy="201168"/>
           </a:xfrm>
           <a:prstGeom prst="rect">
@@ -10468,7 +10228,7 @@
         </p:nvSpPr>
         <p:spPr>
           <a:xfrm>
-            <a:off x="6179515" y="4960620"/>
+            <a:off x="5612587" y="4960620"/>
             <a:ext cx="109728" cy="109728"/>
           </a:xfrm>
           <a:prstGeom prst="ellipse">
@@ -10493,7 +10253,7 @@
         </p:nvSpPr>
         <p:spPr>
           <a:xfrm>
-            <a:off x="6334963" y="4919472"/>
+            <a:off x="5768035" y="4919472"/>
             <a:ext cx="727862" cy="201168"/>
           </a:xfrm>
           <a:prstGeom prst="rect">
@@ -10529,7 +10289,7 @@
         </p:nvSpPr>
         <p:spPr>
           <a:xfrm>
-            <a:off x="7172554" y="4960620"/>
+            <a:off x="6605626" y="4960620"/>
             <a:ext cx="109728" cy="109728"/>
           </a:xfrm>
           <a:prstGeom prst="ellipse">
@@ -10554,7 +10314,7 @@
         </p:nvSpPr>
         <p:spPr>
           <a:xfrm>
-            <a:off x="7328002" y="4919472"/>
+            <a:off x="6761074" y="4919472"/>
             <a:ext cx="925373" cy="201168"/>
           </a:xfrm>
           <a:prstGeom prst="rect">
@@ -10590,7 +10350,7 @@
         </p:nvSpPr>
         <p:spPr>
           <a:xfrm>
-            <a:off x="8363102" y="4960620"/>
+            <a:off x="7796174" y="4960620"/>
             <a:ext cx="109728" cy="109728"/>
           </a:xfrm>
           <a:prstGeom prst="ellipse">
@@ -10615,7 +10375,7 @@
         </p:nvSpPr>
         <p:spPr>
           <a:xfrm>
-            <a:off x="8518550" y="4919472"/>
+            <a:off x="7951622" y="4919472"/>
             <a:ext cx="1057046" cy="201168"/>
           </a:xfrm>
           <a:prstGeom prst="rect">
@@ -10651,7 +10411,7 @@
         </p:nvSpPr>
         <p:spPr>
           <a:xfrm>
-            <a:off x="9685325" y="4960620"/>
+            <a:off x="9118397" y="4960620"/>
             <a:ext cx="109728" cy="109728"/>
           </a:xfrm>
           <a:prstGeom prst="ellipse">
@@ -10676,7 +10436,7 @@
         </p:nvSpPr>
         <p:spPr>
           <a:xfrm>
-            <a:off x="9840773" y="4919472"/>
+            <a:off x="9273845" y="4919472"/>
             <a:ext cx="2373782" cy="201168"/>
           </a:xfrm>
           <a:prstGeom prst="rect">

</xml_diff>

<commit_message>
Forest panels: plot log2 odds ratios on a linear axis
The odds-ratio panels used a log-scaled axis labelled in raw OR, which put the
null off-centre and made the confidence intervals look lopsided. They now plot
log2(OR) with log2 intervals on a linear axis, zero as the null, ticks at the
integers. log2 rather than natural log so the axis reads like the fold changes
used everywhere else in the deck: -1 is half the odds, +1 is double. The caption
keeps the raw odds ratios in prose and says how to read the axis.

Co-Authored-By: Claude Opus 5 <noreply@anthropic.com>
</commit_message>
<xml_diff>
--- a/Analysis/AP1_AlphaGenome_results.pptx
+++ b/Analysis/AP1_AlphaGenome_results.pptx
@@ -122,18 +122,18 @@
   <p:extLst>
     <p:ext uri="{521415D9-36F7-43E2-AB2F-B90AF26B5E84}">
       <p14:sectionLst xmlns:p14="http://schemas.microsoft.com/office/powerpoint/2010/main">
-        <p14:section name="Opening" id="{27a5d981-545e-fd8f-f845-d8f8a5f61d48}">
+        <p14:section name="Opening" id="{547ecadc-eff2-3d7e-5829-afcf254f3224}">
           <p14:sldIdLst>
             <p14:sldId id="256"/>
           </p14:sldIdLst>
         </p14:section>
-        <p14:section name="Design" id="{b0194f64-36d0-4258-82c9-90ae778c10bb}">
+        <p14:section name="Design" id="{9438a710-9c0e-a0e3-5f48-abc5b98ed3af}">
           <p14:sldIdLst>
             <p14:sldId id="257"/>
             <p14:sldId id="258"/>
           </p14:sldIdLst>
         </p14:section>
-        <p14:section name="Findings" id="{550918ff-3762-aa46-57e7-84480359118a}">
+        <p14:section name="Findings" id="{9b25b984-bbf0-acb1-c4eb-e7fb2733c8ef}">
           <p14:sldIdLst>
             <p14:sldId id="259"/>
             <p14:sldId id="260"/>
@@ -148,7 +148,7 @@
             <p14:sldId id="269"/>
           </p14:sldIdLst>
         </p14:section>
-        <p14:section name="Conclusion" id="{11ccf227-0fe8-59cb-3f57-a0b955e537ad}">
+        <p14:section name="Conclusion" id="{c956a467-aba6-0007-7787-75f29e203ba7}">
           <p14:sldIdLst>
             <p14:sldId id="270"/>
             <p14:sldId id="271"/>
@@ -10313,8 +10313,8 @@
         </p:blipFill>
         <p:spPr>
           <a:xfrm>
-            <a:off x="6662171" y="1883664"/>
-            <a:ext cx="4049257" cy="3017520"/>
+            <a:off x="6760062" y="1883664"/>
+            <a:ext cx="3853476" cy="3017520"/>
           </a:xfrm>
           <a:prstGeom prst="rect">
             <a:avLst/>
@@ -10473,7 +10473,7 @@
                   <a:srgbClr val="595959"/>
                 </a:solidFill>
               </a:rPr>
-              <a:t>odds ratio against all Stable sites with a 95% CI; dotted line = no difference.   MEF2, does it have one: Age Up 0.45, Exercise Down 0.56, Dynamic 0.58, all FDR ≤ 0.005.   AP-1, when it has one: Dynamic 1.45, FDR 0.036.</a:t>
+              <a:t>log2 odds ratio against all Stable sites with a 95% CI; dotted line = no difference, so −1 is half the odds and +1 is double.   MEF2, does it have one: Age Up OR 0.45, Exercise Down 0.56, Dynamic 0.58, all FDR ≤ 0.005.   AP-1, when it has one: Dynamic OR 1.45, FDR 0.036.</a:t>
             </a:r>
             <a:endParaRPr lang="en-US" sz="950" dirty="0"/>
           </a:p>

</xml_diff>

<commit_message>
Draw footprints at their true width instead of inflating them to fit a label
Both locus figures sized each footprint chip to whatever its family name needed,
so an 11 bp motif was drawn 40-52 bp wide -- five bins for a feature that spans
one. Footprints are 6 to 39 bp in this data, median 11, and they are now drawn at
exactly that extent on a single rail, with the family name beneath in stacked
rows and a leader line back to the chip it belongs to. The called AP-1 motif is
drawn as the 11 bp it is and labelled by annotation rather than by a box five
times its size.

Affects the method-demonstration locus and the Cdkn1a/Psmd11 example track.

Co-Authored-By: Claude Opus 5 <noreply@anthropic.com>
</commit_message>
<xml_diff>
--- a/Analysis/AP1_AlphaGenome_results.pptx
+++ b/Analysis/AP1_AlphaGenome_results.pptx
@@ -122,19 +122,19 @@
   <p:extLst>
     <p:ext uri="{521415D9-36F7-43E2-AB2F-B90AF26B5E84}">
       <p14:sectionLst xmlns:p14="http://schemas.microsoft.com/office/powerpoint/2010/main">
-        <p14:section name="Opening" id="{68870850-c493-06a4-28c1-ad559e10795f}">
+        <p14:section name="Opening" id="{ab4db3d7-22e7-10d6-2505-8d49fb1ea033}">
           <p14:sldIdLst>
             <p14:sldId id="256"/>
           </p14:sldIdLst>
         </p14:section>
-        <p14:section name="Design" id="{1e8051b2-33b3-dd73-1b7f-30e09f583768}">
+        <p14:section name="Design" id="{080ae629-67bb-fef2-95cc-fb9184ce68d2}">
           <p14:sldIdLst>
             <p14:sldId id="257"/>
             <p14:sldId id="258"/>
             <p14:sldId id="259"/>
           </p14:sldIdLst>
         </p14:section>
-        <p14:section name="Findings" id="{f5bd0b1b-8fbd-2b94-bf7a-7d20d310a2c0}">
+        <p14:section name="Findings" id="{86cc99e6-2e11-4d3c-d21c-5c0f12d4359f}">
           <p14:sldIdLst>
             <p14:sldId id="260"/>
             <p14:sldId id="261"/>
@@ -148,7 +148,7 @@
             <p14:sldId id="269"/>
           </p14:sldIdLst>
         </p14:section>
-        <p14:section name="Conclusion" id="{3e69a788-bdb0-2f61-667a-f3b185f1f5ed}">
+        <p14:section name="Conclusion" id="{9c43fa31-9e8e-3214-85d5-c61e7b6a6edf}">
           <p14:sldIdLst>
             <p14:sldId id="270"/>
             <p14:sldId id="271"/>
@@ -7566,8 +7566,8 @@
         </p:blipFill>
         <p:spPr>
           <a:xfrm>
-            <a:off x="502920" y="1896618"/>
-            <a:ext cx="11155680" cy="2881884"/>
+            <a:off x="594360" y="1737360"/>
+            <a:ext cx="10972800" cy="3200400"/>
           </a:xfrm>
           <a:prstGeom prst="rect">
             <a:avLst/>

</xml_diff>

<commit_message>
Lead the dependence slide with the profiles; add a to-scale edit diagram
The positional profiles show the difference better than the summary dots, so they
now run across the left of the dependence slide at full width, with the three
remaining measures stacked down the right as horizontal dot panels. The
single-best-base panel is dropped. classFigure() gained a stack mode for the
one-measure-per-row layout and optional legend placement, so the legend can sit
under the whole slide rather than inside the narrow column.

Slide 4 gets the method diagram it was missing: the three edits and the control
drawn to scale on a shared axis, so the 11 bp motif, the 170 bp element, the
whole peak and the 300 bp-away control are visibly different sizes rather than
four words. The control row shows the motif it leaves untouched.

Co-Authored-By: Claude Opus 5 <noreply@anthropic.com>
</commit_message>
<xml_diff>
--- a/Analysis/AP1_AlphaGenome_results.pptx
+++ b/Analysis/AP1_AlphaGenome_results.pptx
@@ -122,19 +122,19 @@
   <p:extLst>
     <p:ext uri="{521415D9-36F7-43E2-AB2F-B90AF26B5E84}">
       <p14:sectionLst xmlns:p14="http://schemas.microsoft.com/office/powerpoint/2010/main">
-        <p14:section name="Opening" id="{ab4db3d7-22e7-10d6-2505-8d49fb1ea033}">
+        <p14:section name="Opening" id="{42cd2afe-29fd-82c3-7880-fec3fa0d9a32}">
           <p14:sldIdLst>
             <p14:sldId id="256"/>
           </p14:sldIdLst>
         </p14:section>
-        <p14:section name="Design" id="{080ae629-67bb-fef2-95cc-fb9184ce68d2}">
+        <p14:section name="Design" id="{9a105811-a1f9-2cd7-e5f3-533e4b6e9255}">
           <p14:sldIdLst>
             <p14:sldId id="257"/>
             <p14:sldId id="258"/>
             <p14:sldId id="259"/>
           </p14:sldIdLst>
         </p14:section>
-        <p14:section name="Findings" id="{86cc99e6-2e11-4d3c-d21c-5c0f12d4359f}">
+        <p14:section name="Findings" id="{da75b2ea-f503-3ffa-21b8-538ca9e5d235}">
           <p14:sldIdLst>
             <p14:sldId id="260"/>
             <p14:sldId id="261"/>
@@ -148,7 +148,7 @@
             <p14:sldId id="269"/>
           </p14:sldIdLst>
         </p14:section>
-        <p14:section name="Conclusion" id="{9c43fa31-9e8e-3214-85d5-c61e7b6a6edf}">
+        <p14:section name="Conclusion" id="{e8f4fd0c-1965-5a89-4862-22e2524a15d0}">
           <p14:sldIdLst>
             <p14:sldId id="270"/>
             <p14:sldId id="271"/>
@@ -3125,8 +3125,8 @@
         </p:nvSpPr>
         <p:spPr>
           <a:xfrm>
-            <a:off x="502920" y="1143000"/>
-            <a:ext cx="2743200" cy="256032"/>
+            <a:off x="502920" y="1042416"/>
+            <a:ext cx="6949440" cy="274320"/>
           </a:xfrm>
           <a:prstGeom prst="rect">
             <a:avLst/>
@@ -3142,20 +3142,56 @@
               <a:buNone/>
             </a:pPr>
             <a:r>
-              <a:rPr lang="en-US" sz="1250" b="1" dirty="0">
+              <a:rPr lang="en-US" sz="1350" b="1" dirty="0">
                 <a:solidFill>
                   <a:srgbClr val="111111"/>
                 </a:solidFill>
               </a:rPr>
-              <a:t>Where the dependence sits</a:t>
-            </a:r>
-            <a:endParaRPr lang="en-US" sz="1250" dirty="0"/>
+              <a:t>Where the dependence sits across the element</a:t>
+            </a:r>
+            <a:endParaRPr lang="en-US" sz="1350" dirty="0"/>
+          </a:p>
+        </p:txBody>
+      </p:sp>
+      <p:sp>
+        <p:nvSpPr>
+          <p:cNvPr id="4" name="prof-s1"/>
+          <p:cNvSpPr txBox="1"/>
+          <p:nvPr/>
+        </p:nvSpPr>
+        <p:spPr>
+          <a:xfrm>
+            <a:off x="502920" y="1325880"/>
+            <a:ext cx="6949440" cy="274320"/>
+          </a:xfrm>
+          <a:prstGeom prst="rect">
+            <a:avLst/>
+          </a:prstGeom>
+          <a:noFill/>
+          <a:ln/>
+        </p:spPr>
+        <p:txBody>
+          <a:bodyPr wrap="square" lIns="0" tIns="0" rIns="0" bIns="0" rtlCol="0" anchor="ctr"/>
+          <a:lstStyle/>
+          <a:p>
+            <a:pPr indent="0" marL="0">
+              <a:buNone/>
+            </a:pPr>
+            <a:r>
+              <a:rPr lang="en-US" sz="1050" dirty="0">
+                <a:solidFill>
+                  <a:srgbClr val="595959"/>
+                </a:solidFill>
+              </a:rPr>
+              <a:t>median loss at each of the 60 windows, smoothed over 3; gold band = the ±15 bp core</a:t>
+            </a:r>
+            <a:endParaRPr lang="en-US" sz="1050" dirty="0"/>
           </a:p>
         </p:txBody>
       </p:sp>
       <p:pic>
         <p:nvPicPr>
-          <p:cNvPr id="4" name="Image 0" descr="/Users/z5162865/WongLab/AlphaGenome_Ap1/Analysis/slide_figures/panels/s12_profile_absolute.png">    </p:cNvPr>
+          <p:cNvPr id="5" name="Image 0" descr="/Users/z5162865/WongLab/AlphaGenome_Ap1/Analysis/slide_figures/panels/s12_profile_absolute.png">    </p:cNvPr>
           <p:cNvPicPr>
             <a:picLocks noChangeAspect="1"/>
           </p:cNvPicPr>
@@ -3169,8 +3205,8 @@
         </p:blipFill>
         <p:spPr>
           <a:xfrm>
-            <a:off x="502920" y="1544496"/>
-            <a:ext cx="2743200" cy="1455576"/>
+            <a:off x="1139268" y="1609344"/>
+            <a:ext cx="5676744" cy="1783080"/>
           </a:xfrm>
           <a:prstGeom prst="rect">
             <a:avLst/>
@@ -3179,14 +3215,14 @@
       </p:pic>
       <p:sp>
         <p:nvSpPr>
-          <p:cNvPr id="5" name="prof-t2"/>
+          <p:cNvPr id="6" name="prof-t2"/>
           <p:cNvSpPr txBox="1"/>
           <p:nvPr/>
         </p:nvSpPr>
         <p:spPr>
           <a:xfrm>
-            <a:off x="502920" y="3200400"/>
-            <a:ext cx="2743200" cy="256032"/>
+            <a:off x="502920" y="3456432"/>
+            <a:ext cx="6949440" cy="274320"/>
           </a:xfrm>
           <a:prstGeom prst="rect">
             <a:avLst/>
@@ -3202,20 +3238,56 @@
               <a:buNone/>
             </a:pPr>
             <a:r>
-              <a:rPr lang="en-US" sz="1250" b="1" dirty="0">
+              <a:rPr lang="en-US" sz="1350" b="1" dirty="0">
                 <a:solidFill>
                   <a:srgbClr val="111111"/>
                 </a:solidFill>
               </a:rPr>
-              <a:t>...as a share of each site’s own total</a:t>
-            </a:r>
-            <a:endParaRPr lang="en-US" sz="1250" dirty="0"/>
+              <a:t>...and the same as a share of each site’s own total</a:t>
+            </a:r>
+            <a:endParaRPr lang="en-US" sz="1350" dirty="0"/>
+          </a:p>
+        </p:txBody>
+      </p:sp>
+      <p:sp>
+        <p:nvSpPr>
+          <p:cNvPr id="7" name="prof-s2"/>
+          <p:cNvSpPr txBox="1"/>
+          <p:nvPr/>
+        </p:nvSpPr>
+        <p:spPr>
+          <a:xfrm>
+            <a:off x="502920" y="3721608"/>
+            <a:ext cx="6949440" cy="274320"/>
+          </a:xfrm>
+          <a:prstGeom prst="rect">
+            <a:avLst/>
+          </a:prstGeom>
+          <a:noFill/>
+          <a:ln/>
+        </p:spPr>
+        <p:txBody>
+          <a:bodyPr wrap="square" lIns="0" tIns="0" rIns="0" bIns="0" rtlCol="0" anchor="ctr"/>
+          <a:lstStyle/>
+          <a:p>
+            <a:pPr indent="0" marL="0">
+              <a:buNone/>
+            </a:pPr>
+            <a:r>
+              <a:rPr lang="en-US" sz="1050" dirty="0">
+                <a:solidFill>
+                  <a:srgbClr val="595959"/>
+                </a:solidFill>
+              </a:rPr>
+              <a:t>depth divided out, so only the shape is compared</a:t>
+            </a:r>
+            <a:endParaRPr lang="en-US" sz="1050" dirty="0"/>
           </a:p>
         </p:txBody>
       </p:sp>
       <p:pic>
         <p:nvPicPr>
-          <p:cNvPr id="6" name="Image 1" descr="/Users/z5162865/WongLab/AlphaGenome_Ap1/Analysis/slide_figures/panels/s12_profile_shape.png">    </p:cNvPr>
+          <p:cNvPr id="8" name="Image 1" descr="/Users/z5162865/WongLab/AlphaGenome_Ap1/Analysis/slide_figures/panels/s12_profile_shape.png">    </p:cNvPr>
           <p:cNvPicPr>
             <a:picLocks noChangeAspect="1"/>
           </p:cNvPicPr>
@@ -3229,8 +3301,8 @@
         </p:blipFill>
         <p:spPr>
           <a:xfrm>
-            <a:off x="502920" y="3601896"/>
-            <a:ext cx="2743200" cy="1455576"/>
+            <a:off x="1284825" y="3950208"/>
+            <a:ext cx="5385629" cy="1691640"/>
           </a:xfrm>
           <a:prstGeom prst="rect">
             <a:avLst/>
@@ -3239,14 +3311,14 @@
       </p:pic>
       <p:sp>
         <p:nvSpPr>
-          <p:cNvPr id="7" name="prof-cap"/>
+          <p:cNvPr id="9" name="s3_dependence-title-0"/>
           <p:cNvSpPr txBox="1"/>
           <p:nvPr/>
         </p:nvSpPr>
         <p:spPr>
           <a:xfrm>
-            <a:off x="502920" y="5230368"/>
-            <a:ext cx="2743200" cy="548640"/>
+            <a:off x="7653528" y="1042416"/>
+            <a:ext cx="4005072" cy="237744"/>
           </a:xfrm>
           <a:prstGeom prst="rect">
             <a:avLst/>
@@ -3262,86 +3334,14 @@
               <a:buNone/>
             </a:pPr>
             <a:r>
-              <a:rPr lang="en-US" sz="850" dirty="0">
-                <a:solidFill>
-                  <a:srgbClr val="595959"/>
-                </a:solidFill>
-              </a:rPr>
-              <a:t>median over sites, smoothed over 3 windows; gold band = the ±15 bp core. Stable sites peak highest at the core; Age Up, Exercise Down and Dynamic carry 1.2–1.3× more of their total beyond ±85 bp.</a:t>
-            </a:r>
-            <a:endParaRPr lang="en-US" sz="850" dirty="0"/>
-          </a:p>
-        </p:txBody>
-      </p:sp>
-      <p:sp>
-        <p:nvSpPr>
-          <p:cNvPr id="8" name="s3_dependence-title-0"/>
-          <p:cNvSpPr txBox="1"/>
-          <p:nvPr/>
-        </p:nvSpPr>
-        <p:spPr>
-          <a:xfrm>
-            <a:off x="3401568" y="1143000"/>
-            <a:ext cx="1991106" cy="438912"/>
-          </a:xfrm>
-          <a:prstGeom prst="rect">
-            <a:avLst/>
-          </a:prstGeom>
-          <a:noFill/>
-          <a:ln/>
-        </p:spPr>
-        <p:txBody>
-          <a:bodyPr wrap="square" lIns="0" tIns="0" rIns="0" bIns="0" rtlCol="0" anchor="t"/>
-          <a:lstStyle/>
-          <a:p>
-            <a:pPr indent="0" marL="0">
-              <a:buNone/>
-            </a:pPr>
-            <a:r>
-              <a:rPr lang="en-US" sz="1250" b="1" dirty="0">
+              <a:rPr lang="en-US" sz="1150" b="1" dirty="0">
                 <a:solidFill>
                   <a:srgbClr val="111111"/>
                 </a:solidFill>
               </a:rPr>
               <a:t>Dependence near the motif</a:t>
             </a:r>
-            <a:endParaRPr lang="en-US" sz="1250" dirty="0"/>
-          </a:p>
-        </p:txBody>
-      </p:sp>
-      <p:sp>
-        <p:nvSpPr>
-          <p:cNvPr id="9" name="s3_dependence-sub-0"/>
-          <p:cNvSpPr txBox="1"/>
-          <p:nvPr/>
-        </p:nvSpPr>
-        <p:spPr>
-          <a:xfrm>
-            <a:off x="3401568" y="1572768"/>
-            <a:ext cx="1991106" cy="310896"/>
-          </a:xfrm>
-          <a:prstGeom prst="rect">
-            <a:avLst/>
-          </a:prstGeom>
-          <a:noFill/>
-          <a:ln/>
-        </p:spPr>
-        <p:txBody>
-          <a:bodyPr wrap="square" lIns="0" tIns="0" rIns="0" bIns="0" rtlCol="0" anchor="t"/>
-          <a:lstStyle/>
-          <a:p>
-            <a:pPr indent="0" marL="0">
-              <a:buNone/>
-            </a:pPr>
-            <a:r>
-              <a:rPr lang="en-US" sz="950" dirty="0">
-                <a:solidFill>
-                  <a:srgbClr val="595959"/>
-                </a:solidFill>
-              </a:rPr>
-              <a:t>loss summed over windows within ±85 bp</a:t>
-            </a:r>
-            <a:endParaRPr lang="en-US" sz="950" dirty="0"/>
+            <a:endParaRPr lang="en-US" sz="1150" dirty="0"/>
           </a:p>
         </p:txBody>
       </p:sp>
@@ -3361,8 +3361,8 @@
         </p:blipFill>
         <p:spPr>
           <a:xfrm>
-            <a:off x="3401568" y="2395936"/>
-            <a:ext cx="1991106" cy="1810096"/>
+            <a:off x="7653963" y="1298448"/>
+            <a:ext cx="4004201" cy="1274064"/>
           </a:xfrm>
           <a:prstGeom prst="rect">
             <a:avLst/>
@@ -3377,73 +3377,37 @@
         </p:nvSpPr>
         <p:spPr>
           <a:xfrm>
-            <a:off x="5465826" y="1143000"/>
-            <a:ext cx="1991106" cy="438912"/>
-          </a:xfrm>
-          <a:prstGeom prst="rect">
-            <a:avLst/>
-          </a:prstGeom>
-          <a:noFill/>
-          <a:ln/>
-        </p:spPr>
-        <p:txBody>
-          <a:bodyPr wrap="square" lIns="0" tIns="0" rIns="0" bIns="0" rtlCol="0" anchor="t"/>
+            <a:off x="7653528" y="2627376"/>
+            <a:ext cx="4005072" cy="237744"/>
+          </a:xfrm>
+          <a:prstGeom prst="rect">
+            <a:avLst/>
+          </a:prstGeom>
+          <a:noFill/>
+          <a:ln/>
+        </p:spPr>
+        <p:txBody>
+          <a:bodyPr wrap="square" lIns="0" tIns="0" rIns="0" bIns="0" rtlCol="0" anchor="ctr"/>
           <a:lstStyle/>
           <a:p>
             <a:pPr indent="0" marL="0">
               <a:buNone/>
             </a:pPr>
             <a:r>
-              <a:rPr lang="en-US" sz="1250" b="1" dirty="0">
+              <a:rPr lang="en-US" sz="1150" b="1" dirty="0">
                 <a:solidFill>
                   <a:srgbClr val="111111"/>
                 </a:solidFill>
               </a:rPr>
               <a:t>Dependence out in the context</a:t>
             </a:r>
-            <a:endParaRPr lang="en-US" sz="1250" dirty="0"/>
-          </a:p>
-        </p:txBody>
-      </p:sp>
-      <p:sp>
-        <p:nvSpPr>
-          <p:cNvPr id="12" name="s3_dependence-sub-1"/>
-          <p:cNvSpPr txBox="1"/>
-          <p:nvPr/>
-        </p:nvSpPr>
-        <p:spPr>
-          <a:xfrm>
-            <a:off x="5465826" y="1572768"/>
-            <a:ext cx="1991106" cy="310896"/>
-          </a:xfrm>
-          <a:prstGeom prst="rect">
-            <a:avLst/>
-          </a:prstGeom>
-          <a:noFill/>
-          <a:ln/>
-        </p:spPr>
-        <p:txBody>
-          <a:bodyPr wrap="square" lIns="0" tIns="0" rIns="0" bIns="0" rtlCol="0" anchor="t"/>
-          <a:lstStyle/>
-          <a:p>
-            <a:pPr indent="0" marL="0">
-              <a:buNone/>
-            </a:pPr>
-            <a:r>
-              <a:rPr lang="en-US" sz="950" dirty="0">
-                <a:solidFill>
-                  <a:srgbClr val="595959"/>
-                </a:solidFill>
-              </a:rPr>
-              <a:t>loss summed over windows beyond that</a:t>
-            </a:r>
-            <a:endParaRPr lang="en-US" sz="950" dirty="0"/>
+            <a:endParaRPr lang="en-US" sz="1150" dirty="0"/>
           </a:p>
         </p:txBody>
       </p:sp>
       <p:pic>
         <p:nvPicPr>
-          <p:cNvPr id="13" name="Image 3" descr="/Users/z5162865/WongLab/AlphaGenome_Ap1/Analysis/slide_figures/panels/s3_dependence_c1_r0.png">    </p:cNvPr>
+          <p:cNvPr id="12" name="Image 3" descr="/Users/z5162865/WongLab/AlphaGenome_Ap1/Analysis/slide_figures/panels/s3_dependence_c1_r0.png">    </p:cNvPr>
           <p:cNvPicPr>
             <a:picLocks noChangeAspect="1"/>
           </p:cNvPicPr>
@@ -3457,8 +3421,8 @@
         </p:blipFill>
         <p:spPr>
           <a:xfrm>
-            <a:off x="5465826" y="2395936"/>
-            <a:ext cx="1991106" cy="1810096"/>
+            <a:off x="7653963" y="2883408"/>
+            <a:ext cx="4004201" cy="1274064"/>
           </a:xfrm>
           <a:prstGeom prst="rect">
             <a:avLst/>
@@ -3467,79 +3431,43 @@
       </p:pic>
       <p:sp>
         <p:nvSpPr>
-          <p:cNvPr id="14" name="s3_dependence-title-2"/>
+          <p:cNvPr id="13" name="s3_dependence-title-2"/>
           <p:cNvSpPr txBox="1"/>
           <p:nvPr/>
         </p:nvSpPr>
         <p:spPr>
           <a:xfrm>
-            <a:off x="7530084" y="1143000"/>
-            <a:ext cx="1991106" cy="438912"/>
-          </a:xfrm>
-          <a:prstGeom prst="rect">
-            <a:avLst/>
-          </a:prstGeom>
-          <a:noFill/>
-          <a:ln/>
-        </p:spPr>
-        <p:txBody>
-          <a:bodyPr wrap="square" lIns="0" tIns="0" rIns="0" bIns="0" rtlCol="0" anchor="t"/>
+            <a:off x="7653528" y="4212336"/>
+            <a:ext cx="4005072" cy="237744"/>
+          </a:xfrm>
+          <a:prstGeom prst="rect">
+            <a:avLst/>
+          </a:prstGeom>
+          <a:noFill/>
+          <a:ln/>
+        </p:spPr>
+        <p:txBody>
+          <a:bodyPr wrap="square" lIns="0" tIns="0" rIns="0" bIns="0" rtlCol="0" anchor="ctr"/>
           <a:lstStyle/>
           <a:p>
             <a:pPr indent="0" marL="0">
               <a:buNone/>
             </a:pPr>
             <a:r>
-              <a:rPr lang="en-US" sz="1250" b="1" dirty="0">
+              <a:rPr lang="en-US" sz="1150" b="1" dirty="0">
                 <a:solidFill>
                   <a:srgbClr val="111111"/>
                 </a:solidFill>
               </a:rPr>
               <a:t>Spread along the element</a:t>
             </a:r>
-            <a:endParaRPr lang="en-US" sz="1250" dirty="0"/>
-          </a:p>
-        </p:txBody>
-      </p:sp>
-      <p:sp>
-        <p:nvSpPr>
-          <p:cNvPr id="15" name="s3_dependence-sub-2"/>
-          <p:cNvSpPr txBox="1"/>
-          <p:nvPr/>
-        </p:nvSpPr>
-        <p:spPr>
-          <a:xfrm>
-            <a:off x="7530084" y="1572768"/>
-            <a:ext cx="1991106" cy="310896"/>
-          </a:xfrm>
-          <a:prstGeom prst="rect">
-            <a:avLst/>
-          </a:prstGeom>
-          <a:noFill/>
-          <a:ln/>
-        </p:spPr>
-        <p:txBody>
-          <a:bodyPr wrap="square" lIns="0" tIns="0" rIns="0" bIns="0" rtlCol="0" anchor="t"/>
-          <a:lstStyle/>
-          <a:p>
-            <a:pPr indent="0" marL="0">
-              <a:buNone/>
-            </a:pPr>
-            <a:r>
-              <a:rPr lang="en-US" sz="950" dirty="0">
-                <a:solidFill>
-                  <a:srgbClr val="595959"/>
-                </a:solidFill>
-              </a:rPr>
-              <a:t>SD of window position, weighted by loss</a:t>
-            </a:r>
-            <a:endParaRPr lang="en-US" sz="950" dirty="0"/>
+            <a:endParaRPr lang="en-US" sz="1150" dirty="0"/>
           </a:p>
         </p:txBody>
       </p:sp>
       <p:pic>
         <p:nvPicPr>
-          <p:cNvPr id="16" name="Image 4" descr="/Users/z5162865/WongLab/AlphaGenome_Ap1/Analysis/slide_figures/panels/s3_dependence_c2_r0.png">    </p:cNvPr>
+          <p:cNvPr id="14" name="Image 4" descr="/Users/z5162865/WongLab/AlphaGenome_Ap1/Analysis/slide_figures/panels/s3_dependence_c2_r0.png">    </p:cNvPr>
           <p:cNvPicPr>
             <a:picLocks noChangeAspect="1"/>
           </p:cNvPicPr>
@@ -3553,8 +3481,8 @@
         </p:blipFill>
         <p:spPr>
           <a:xfrm>
-            <a:off x="7530084" y="2395936"/>
-            <a:ext cx="1991106" cy="1810096"/>
+            <a:off x="7653963" y="4468368"/>
+            <a:ext cx="4004201" cy="1274064"/>
           </a:xfrm>
           <a:prstGeom prst="rect">
             <a:avLst/>
@@ -3563,109 +3491,13 @@
       </p:pic>
       <p:sp>
         <p:nvSpPr>
-          <p:cNvPr id="17" name="s3_dependence-title-3"/>
-          <p:cNvSpPr txBox="1"/>
-          <p:nvPr/>
-        </p:nvSpPr>
-        <p:spPr>
-          <a:xfrm>
-            <a:off x="9594342" y="1143000"/>
-            <a:ext cx="1991106" cy="438912"/>
-          </a:xfrm>
-          <a:prstGeom prst="rect">
-            <a:avLst/>
-          </a:prstGeom>
-          <a:noFill/>
-          <a:ln/>
-        </p:spPr>
-        <p:txBody>
-          <a:bodyPr wrap="square" lIns="0" tIns="0" rIns="0" bIns="0" rtlCol="0" anchor="t"/>
-          <a:lstStyle/>
-          <a:p>
-            <a:pPr indent="0" marL="0">
-              <a:buNone/>
-            </a:pPr>
-            <a:r>
-              <a:rPr lang="en-US" sz="1250" b="1" dirty="0">
-                <a:solidFill>
-                  <a:srgbClr val="111111"/>
-                </a:solidFill>
-              </a:rPr>
-              <a:t>Depth of the single best base</a:t>
-            </a:r>
-            <a:endParaRPr lang="en-US" sz="1250" dirty="0"/>
-          </a:p>
-        </p:txBody>
-      </p:sp>
-      <p:sp>
-        <p:nvSpPr>
-          <p:cNvPr id="18" name="s3_dependence-sub-3"/>
-          <p:cNvSpPr txBox="1"/>
-          <p:nvPr/>
-        </p:nvSpPr>
-        <p:spPr>
-          <a:xfrm>
-            <a:off x="9594342" y="1572768"/>
-            <a:ext cx="1991106" cy="310896"/>
-          </a:xfrm>
-          <a:prstGeom prst="rect">
-            <a:avLst/>
-          </a:prstGeom>
-          <a:noFill/>
-          <a:ln/>
-        </p:spPr>
-        <p:txBody>
-          <a:bodyPr wrap="square" lIns="0" tIns="0" rIns="0" bIns="0" rtlCol="0" anchor="t"/>
-          <a:lstStyle/>
-          <a:p>
-            <a:pPr indent="0" marL="0">
-              <a:buNone/>
-            </a:pPr>
-            <a:r>
-              <a:rPr lang="en-US" sz="950" dirty="0">
-                <a:solidFill>
-                  <a:srgbClr val="595959"/>
-                </a:solidFill>
-              </a:rPr>
-              <a:t>largest effect of any one base change, ±30 bp</a:t>
-            </a:r>
-            <a:endParaRPr lang="en-US" sz="950" dirty="0"/>
-          </a:p>
-        </p:txBody>
-      </p:sp>
-      <p:pic>
-        <p:nvPicPr>
-          <p:cNvPr id="19" name="Image 5" descr="/Users/z5162865/WongLab/AlphaGenome_Ap1/Analysis/slide_figures/panels/s3_dependence_c3_r0.png">    </p:cNvPr>
-          <p:cNvPicPr>
-            <a:picLocks noChangeAspect="1"/>
-          </p:cNvPicPr>
-          <p:nvPr/>
-        </p:nvPicPr>
-        <p:blipFill>
-          <a:blip r:embed="rId6"/>
-          <a:stretch>
-            <a:fillRect/>
-          </a:stretch>
-        </p:blipFill>
-        <p:spPr>
-          <a:xfrm>
-            <a:off x="9594342" y="2395936"/>
-            <a:ext cx="1991106" cy="1810096"/>
-          </a:xfrm>
-          <a:prstGeom prst="rect">
-            <a:avLst/>
-          </a:prstGeom>
-        </p:spPr>
-      </p:pic>
-      <p:sp>
-        <p:nvSpPr>
-          <p:cNvPr id="20" name="s3_dependence-dot-0"/>
+          <p:cNvPr id="15" name="s3_dependence-dot-0"/>
           <p:cNvSpPr/>
           <p:nvPr/>
         </p:nvSpPr>
         <p:spPr>
           <a:xfrm>
-            <a:off x="3291840" y="4914900"/>
+            <a:off x="502920" y="5765292"/>
             <a:ext cx="109728" cy="109728"/>
           </a:xfrm>
           <a:prstGeom prst="ellipse">
@@ -3684,13 +3516,13 @@
       </p:sp>
       <p:sp>
         <p:nvSpPr>
-          <p:cNvPr id="21" name="s3_dependence-leg-0"/>
+          <p:cNvPr id="16" name="s3_dependence-leg-0"/>
           <p:cNvSpPr txBox="1"/>
           <p:nvPr/>
         </p:nvSpPr>
         <p:spPr>
           <a:xfrm>
-            <a:off x="3447288" y="4873752"/>
+            <a:off x="658368" y="5724144"/>
             <a:ext cx="1057046" cy="201168"/>
           </a:xfrm>
           <a:prstGeom prst="rect">
@@ -3720,13 +3552,13 @@
       </p:sp>
       <p:sp>
         <p:nvSpPr>
-          <p:cNvPr id="22" name="s3_dependence-dot-1"/>
+          <p:cNvPr id="17" name="s3_dependence-dot-1"/>
           <p:cNvSpPr/>
           <p:nvPr/>
         </p:nvSpPr>
         <p:spPr>
           <a:xfrm>
-            <a:off x="4614062" y="4914900"/>
+            <a:off x="1825142" y="5765292"/>
             <a:ext cx="109728" cy="109728"/>
           </a:xfrm>
           <a:prstGeom prst="ellipse">
@@ -3745,13 +3577,13 @@
       </p:sp>
       <p:sp>
         <p:nvSpPr>
-          <p:cNvPr id="23" name="s3_dependence-leg-1"/>
+          <p:cNvPr id="18" name="s3_dependence-leg-1"/>
           <p:cNvSpPr txBox="1"/>
           <p:nvPr/>
         </p:nvSpPr>
         <p:spPr>
           <a:xfrm>
-            <a:off x="4769510" y="4873752"/>
+            <a:off x="1980590" y="5724144"/>
             <a:ext cx="596189" cy="201168"/>
           </a:xfrm>
           <a:prstGeom prst="rect">
@@ -3781,13 +3613,13 @@
       </p:sp>
       <p:sp>
         <p:nvSpPr>
-          <p:cNvPr id="24" name="s3_dependence-dot-2"/>
+          <p:cNvPr id="19" name="s3_dependence-dot-2"/>
           <p:cNvSpPr/>
           <p:nvPr/>
         </p:nvSpPr>
         <p:spPr>
           <a:xfrm>
-            <a:off x="5475427" y="4914900"/>
+            <a:off x="2686507" y="5765292"/>
             <a:ext cx="109728" cy="109728"/>
           </a:xfrm>
           <a:prstGeom prst="ellipse">
@@ -3806,13 +3638,13 @@
       </p:sp>
       <p:sp>
         <p:nvSpPr>
-          <p:cNvPr id="25" name="s3_dependence-leg-2"/>
+          <p:cNvPr id="20" name="s3_dependence-leg-2"/>
           <p:cNvSpPr txBox="1"/>
           <p:nvPr/>
         </p:nvSpPr>
         <p:spPr>
           <a:xfrm>
-            <a:off x="5630875" y="4873752"/>
+            <a:off x="2841955" y="5724144"/>
             <a:ext cx="727862" cy="201168"/>
           </a:xfrm>
           <a:prstGeom prst="rect">
@@ -3842,13 +3674,13 @@
       </p:sp>
       <p:sp>
         <p:nvSpPr>
-          <p:cNvPr id="26" name="s3_dependence-dot-3"/>
+          <p:cNvPr id="21" name="s3_dependence-dot-3"/>
           <p:cNvSpPr/>
           <p:nvPr/>
         </p:nvSpPr>
         <p:spPr>
           <a:xfrm>
-            <a:off x="6468466" y="4914900"/>
+            <a:off x="3679546" y="5765292"/>
             <a:ext cx="109728" cy="109728"/>
           </a:xfrm>
           <a:prstGeom prst="ellipse">
@@ -3867,13 +3699,13 @@
       </p:sp>
       <p:sp>
         <p:nvSpPr>
-          <p:cNvPr id="27" name="s3_dependence-leg-3"/>
+          <p:cNvPr id="22" name="s3_dependence-leg-3"/>
           <p:cNvSpPr txBox="1"/>
           <p:nvPr/>
         </p:nvSpPr>
         <p:spPr>
           <a:xfrm>
-            <a:off x="6623914" y="4873752"/>
+            <a:off x="3834994" y="5724144"/>
             <a:ext cx="925373" cy="201168"/>
           </a:xfrm>
           <a:prstGeom prst="rect">
@@ -3903,13 +3735,13 @@
       </p:sp>
       <p:sp>
         <p:nvSpPr>
-          <p:cNvPr id="28" name="s3_dependence-dot-4"/>
+          <p:cNvPr id="23" name="s3_dependence-dot-4"/>
           <p:cNvSpPr/>
           <p:nvPr/>
         </p:nvSpPr>
         <p:spPr>
           <a:xfrm>
-            <a:off x="7659014" y="4914900"/>
+            <a:off x="4870094" y="5765292"/>
             <a:ext cx="109728" cy="109728"/>
           </a:xfrm>
           <a:prstGeom prst="ellipse">
@@ -3928,13 +3760,13 @@
       </p:sp>
       <p:sp>
         <p:nvSpPr>
-          <p:cNvPr id="29" name="s3_dependence-leg-4"/>
+          <p:cNvPr id="24" name="s3_dependence-leg-4"/>
           <p:cNvSpPr txBox="1"/>
           <p:nvPr/>
         </p:nvSpPr>
         <p:spPr>
           <a:xfrm>
-            <a:off x="7814462" y="4873752"/>
+            <a:off x="5025542" y="5724144"/>
             <a:ext cx="1057046" cy="201168"/>
           </a:xfrm>
           <a:prstGeom prst="rect">
@@ -3964,13 +3796,13 @@
       </p:sp>
       <p:sp>
         <p:nvSpPr>
-          <p:cNvPr id="30" name="s3_dependence-dot-5"/>
+          <p:cNvPr id="25" name="s3_dependence-dot-5"/>
           <p:cNvSpPr/>
           <p:nvPr/>
         </p:nvSpPr>
         <p:spPr>
           <a:xfrm>
-            <a:off x="8981237" y="4914900"/>
+            <a:off x="6192317" y="5765292"/>
             <a:ext cx="109728" cy="109728"/>
           </a:xfrm>
           <a:prstGeom prst="ellipse">
@@ -3989,13 +3821,13 @@
       </p:sp>
       <p:sp>
         <p:nvSpPr>
-          <p:cNvPr id="31" name="s3_dependence-leg-5"/>
+          <p:cNvPr id="26" name="s3_dependence-leg-5"/>
           <p:cNvSpPr txBox="1"/>
           <p:nvPr/>
         </p:nvSpPr>
         <p:spPr>
           <a:xfrm>
-            <a:off x="9136685" y="4873752"/>
+            <a:off x="6347765" y="5724144"/>
             <a:ext cx="1781251" cy="201168"/>
           </a:xfrm>
           <a:prstGeom prst="rect">
@@ -4025,43 +3857,7 @@
       </p:sp>
       <p:sp>
         <p:nvSpPr>
-          <p:cNvPr id="32" name="s3_dependence-key"/>
-          <p:cNvSpPr txBox="1"/>
-          <p:nvPr/>
-        </p:nvSpPr>
-        <p:spPr>
-          <a:xfrm>
-            <a:off x="3291840" y="5148072"/>
-            <a:ext cx="8366760" cy="502920"/>
-          </a:xfrm>
-          <a:prstGeom prst="rect">
-            <a:avLst/>
-          </a:prstGeom>
-          <a:noFill/>
-          <a:ln/>
-        </p:spPr>
-        <p:txBody>
-          <a:bodyPr wrap="square" lIns="0" tIns="0" rIns="0" bIns="0" rtlCol="0" anchor="ctr"/>
-          <a:lstStyle/>
-          <a:p>
-            <a:pPr indent="0" marL="0">
-              <a:buNone/>
-            </a:pPr>
-            <a:r>
-              <a:rPr lang="en-US" sz="900" dirty="0">
-                <a:solidFill>
-                  <a:srgbClr val="595959"/>
-                </a:solidFill>
-              </a:rPr>
-              <a:t>grey line and band: all 2,907 Stable sites, median with a 95% bootstrap CI.   Each class is every site carrying that call, tested against that reference by Mann–Whitney, BH across all 20 tests on this figure.   *** p&lt;0.001   ** p&lt;0.01   * p&lt;0.05   ns ≥ 0.05</a:t>
-            </a:r>
-            <a:endParaRPr lang="en-US" sz="900" dirty="0"/>
-          </a:p>
-        </p:txBody>
-      </p:sp>
-      <p:sp>
-        <p:nvSpPr>
-          <p:cNvPr id="33" name="Text 0"/>
+          <p:cNvPr id="27" name="Text 0"/>
           <p:cNvSpPr/>
           <p:nvPr>
             <p:ph idx="101" type="body" hasCustomPrompt="1"/>
@@ -7769,23 +7565,23 @@
       </p:sp>
       <p:sp>
         <p:nvSpPr>
-          <p:cNvPr id="3" name="s2_matched_null-title-0"/>
+          <p:cNvPr id="3" name="ed-t"/>
           <p:cNvSpPr txBox="1"/>
           <p:nvPr/>
         </p:nvSpPr>
         <p:spPr>
           <a:xfrm>
-            <a:off x="612648" y="1143000"/>
-            <a:ext cx="2688336" cy="438912"/>
-          </a:xfrm>
-          <a:prstGeom prst="rect">
-            <a:avLst/>
-          </a:prstGeom>
-          <a:noFill/>
-          <a:ln/>
-        </p:spPr>
-        <p:txBody>
-          <a:bodyPr wrap="square" lIns="0" tIns="0" rIns="0" bIns="0" rtlCol="0" anchor="t"/>
+            <a:off x="502920" y="987552"/>
+            <a:ext cx="4937760" cy="256032"/>
+          </a:xfrm>
+          <a:prstGeom prst="rect">
+            <a:avLst/>
+          </a:prstGeom>
+          <a:noFill/>
+          <a:ln/>
+        </p:spPr>
+        <p:txBody>
+          <a:bodyPr wrap="square" lIns="0" tIns="0" rIns="0" bIns="0" rtlCol="0" anchor="ctr"/>
           <a:lstStyle/>
           <a:p>
             <a:pPr indent="0" marL="0">
@@ -7797,51 +7593,15 @@
                   <a:srgbClr val="111111"/>
                 </a:solidFill>
               </a:rPr>
-              <a:t>Replace the 11 bp motif</a:t>
+              <a:t>The three edits, and the control</a:t>
             </a:r>
             <a:endParaRPr lang="en-US" sz="1250" dirty="0"/>
-          </a:p>
-        </p:txBody>
-      </p:sp>
-      <p:sp>
-        <p:nvSpPr>
-          <p:cNvPr id="4" name="s2_matched_null-sub-0"/>
-          <p:cNvSpPr txBox="1"/>
-          <p:nvPr/>
-        </p:nvSpPr>
-        <p:spPr>
-          <a:xfrm>
-            <a:off x="612648" y="1572768"/>
-            <a:ext cx="2688336" cy="310896"/>
-          </a:xfrm>
-          <a:prstGeom prst="rect">
-            <a:avLst/>
-          </a:prstGeom>
-          <a:noFill/>
-          <a:ln/>
-        </p:spPr>
-        <p:txBody>
-          <a:bodyPr wrap="square" lIns="0" tIns="0" rIns="0" bIns="0" rtlCol="0" anchor="t"/>
-          <a:lstStyle/>
-          <a:p>
-            <a:pPr indent="0" marL="0">
-              <a:buNone/>
-            </a:pPr>
-            <a:r>
-              <a:rPr lang="en-US" sz="950" dirty="0">
-                <a:solidFill>
-                  <a:srgbClr val="595959"/>
-                </a:solidFill>
-              </a:rPr>
-              <a:t>the motif alone</a:t>
-            </a:r>
-            <a:endParaRPr lang="en-US" sz="950" dirty="0"/>
           </a:p>
         </p:txBody>
       </p:sp>
       <p:pic>
         <p:nvPicPr>
-          <p:cNvPr id="5" name="Image 0" descr="/Users/z5162865/WongLab/AlphaGenome_Ap1/Analysis/slide_figures/panels/s2_matched_null_c0_r0.png">    </p:cNvPr>
+          <p:cNvPr id="4" name="Image 0" descr="/Users/z5162865/WongLab/AlphaGenome_Ap1/Analysis/slide_figures/panels/d_edits.png">    </p:cNvPr>
           <p:cNvPicPr>
             <a:picLocks noChangeAspect="1"/>
           </p:cNvPicPr>
@@ -7855,8 +7615,8 @@
         </p:blipFill>
         <p:spPr>
           <a:xfrm>
-            <a:off x="612648" y="2079013"/>
-            <a:ext cx="2688336" cy="2443942"/>
+            <a:off x="1008944" y="1261872"/>
+            <a:ext cx="3925711" cy="1188720"/>
           </a:xfrm>
           <a:prstGeom prst="rect">
             <a:avLst/>
@@ -7865,13 +7625,13 @@
       </p:pic>
       <p:sp>
         <p:nvSpPr>
-          <p:cNvPr id="6" name="s2_matched_null-title-1"/>
+          <p:cNvPr id="5" name="s2_matched_null-title-0"/>
           <p:cNvSpPr txBox="1"/>
           <p:nvPr/>
         </p:nvSpPr>
         <p:spPr>
           <a:xfrm>
-            <a:off x="3374136" y="1143000"/>
+            <a:off x="612648" y="2578608"/>
             <a:ext cx="2688336" cy="438912"/>
           </a:xfrm>
           <a:prstGeom prst="rect">
@@ -7893,7 +7653,7 @@
                   <a:srgbClr val="111111"/>
                 </a:solidFill>
               </a:rPr>
-              <a:t>Replace the 170 bp element</a:t>
+              <a:t>Replace the 11 bp motif</a:t>
             </a:r>
             <a:endParaRPr lang="en-US" sz="1250" dirty="0"/>
           </a:p>
@@ -7901,13 +7661,13 @@
       </p:sp>
       <p:sp>
         <p:nvSpPr>
-          <p:cNvPr id="7" name="s2_matched_null-sub-1"/>
+          <p:cNvPr id="6" name="s2_matched_null-sub-0"/>
           <p:cNvSpPr txBox="1"/>
           <p:nvPr/>
         </p:nvSpPr>
         <p:spPr>
           <a:xfrm>
-            <a:off x="3374136" y="1572768"/>
+            <a:off x="612648" y="3008376"/>
             <a:ext cx="2688336" cy="310896"/>
           </a:xfrm>
           <a:prstGeom prst="rect">
@@ -7929,7 +7689,7 @@
                   <a:srgbClr val="595959"/>
                 </a:solidFill>
               </a:rPr>
-              <a:t>the element around it</a:t>
+              <a:t>the motif alone</a:t>
             </a:r>
             <a:endParaRPr lang="en-US" sz="950" dirty="0"/>
           </a:p>
@@ -7937,7 +7697,7 @@
       </p:sp>
       <p:pic>
         <p:nvPicPr>
-          <p:cNvPr id="8" name="Image 1" descr="/Users/z5162865/WongLab/AlphaGenome_Ap1/Analysis/slide_figures/panels/s2_matched_null_c1_r0.png">    </p:cNvPr>
+          <p:cNvPr id="7" name="Image 1" descr="/Users/z5162865/WongLab/AlphaGenome_Ap1/Analysis/slide_figures/panels/s2_matched_null_c0_r0.png">    </p:cNvPr>
           <p:cNvPicPr>
             <a:picLocks noChangeAspect="1"/>
           </p:cNvPicPr>
@@ -7951,8 +7711,8 @@
         </p:blipFill>
         <p:spPr>
           <a:xfrm>
-            <a:off x="3374136" y="2079013"/>
-            <a:ext cx="2688336" cy="2443942"/>
+            <a:off x="1222553" y="3328416"/>
+            <a:ext cx="1468526" cy="1335024"/>
           </a:xfrm>
           <a:prstGeom prst="rect">
             <a:avLst/>
@@ -7961,13 +7721,13 @@
       </p:pic>
       <p:sp>
         <p:nvSpPr>
-          <p:cNvPr id="9" name="s2_matched_null-title-2"/>
+          <p:cNvPr id="8" name="s2_matched_null-title-1"/>
           <p:cNvSpPr txBox="1"/>
           <p:nvPr/>
         </p:nvSpPr>
         <p:spPr>
           <a:xfrm>
-            <a:off x="6135624" y="1143000"/>
+            <a:off x="3374136" y="2578608"/>
             <a:ext cx="2688336" cy="438912"/>
           </a:xfrm>
           <a:prstGeom prst="rect">
@@ -7989,7 +7749,7 @@
                   <a:srgbClr val="111111"/>
                 </a:solidFill>
               </a:rPr>
-              <a:t>Replace the whole peak</a:t>
+              <a:t>Replace the 170 bp element</a:t>
             </a:r>
             <a:endParaRPr lang="en-US" sz="1250" dirty="0"/>
           </a:p>
@@ -7997,13 +7757,13 @@
       </p:sp>
       <p:sp>
         <p:nvSpPr>
-          <p:cNvPr id="10" name="s2_matched_null-sub-2"/>
+          <p:cNvPr id="9" name="s2_matched_null-sub-1"/>
           <p:cNvSpPr txBox="1"/>
           <p:nvPr/>
         </p:nvSpPr>
         <p:spPr>
           <a:xfrm>
-            <a:off x="6135624" y="1572768"/>
+            <a:off x="3374136" y="3008376"/>
             <a:ext cx="2688336" cy="310896"/>
           </a:xfrm>
           <a:prstGeom prst="rect">
@@ -8025,7 +7785,7 @@
                   <a:srgbClr val="595959"/>
                 </a:solidFill>
               </a:rPr>
-              <a:t>everything, read over the peak</a:t>
+              <a:t>the element around it</a:t>
             </a:r>
             <a:endParaRPr lang="en-US" sz="950" dirty="0"/>
           </a:p>
@@ -8033,7 +7793,7 @@
       </p:sp>
       <p:pic>
         <p:nvPicPr>
-          <p:cNvPr id="11" name="Image 2" descr="/Users/z5162865/WongLab/AlphaGenome_Ap1/Analysis/slide_figures/panels/s2_matched_null_c2_r0.png">    </p:cNvPr>
+          <p:cNvPr id="10" name="Image 2" descr="/Users/z5162865/WongLab/AlphaGenome_Ap1/Analysis/slide_figures/panels/s2_matched_null_c1_r0.png">    </p:cNvPr>
           <p:cNvPicPr>
             <a:picLocks noChangeAspect="1"/>
           </p:cNvPicPr>
@@ -8047,8 +7807,8 @@
         </p:blipFill>
         <p:spPr>
           <a:xfrm>
-            <a:off x="6135624" y="2079013"/>
-            <a:ext cx="2688336" cy="2443942"/>
+            <a:off x="3984041" y="3328416"/>
+            <a:ext cx="1468526" cy="1335024"/>
           </a:xfrm>
           <a:prstGeom prst="rect">
             <a:avLst/>
@@ -8057,13 +7817,13 @@
       </p:pic>
       <p:sp>
         <p:nvSpPr>
-          <p:cNvPr id="12" name="s2_matched_null-title-3"/>
+          <p:cNvPr id="11" name="s2_matched_null-title-2"/>
           <p:cNvSpPr txBox="1"/>
           <p:nvPr/>
         </p:nvSpPr>
         <p:spPr>
           <a:xfrm>
-            <a:off x="8897112" y="1143000"/>
+            <a:off x="6135624" y="2578608"/>
             <a:ext cx="2688336" cy="438912"/>
           </a:xfrm>
           <a:prstGeom prst="rect">
@@ -8085,7 +7845,7 @@
                   <a:srgbClr val="111111"/>
                 </a:solidFill>
               </a:rPr>
-              <a:t>Edit 300 bp away</a:t>
+              <a:t>Replace the whole peak</a:t>
             </a:r>
             <a:endParaRPr lang="en-US" sz="1250" dirty="0"/>
           </a:p>
@@ -8093,13 +7853,13 @@
       </p:sp>
       <p:sp>
         <p:nvSpPr>
-          <p:cNvPr id="13" name="s2_matched_null-sub-3"/>
+          <p:cNvPr id="12" name="s2_matched_null-sub-2"/>
           <p:cNvSpPr txBox="1"/>
           <p:nvPr/>
         </p:nvSpPr>
         <p:spPr>
           <a:xfrm>
-            <a:off x="8897112" y="1572768"/>
+            <a:off x="6135624" y="3008376"/>
             <a:ext cx="2688336" cy="310896"/>
           </a:xfrm>
           <a:prstGeom prst="rect">
@@ -8121,7 +7881,7 @@
                   <a:srgbClr val="595959"/>
                 </a:solidFill>
               </a:rPr>
-              <a:t>the control: nothing at stake</a:t>
+              <a:t>everything, read over the peak</a:t>
             </a:r>
             <a:endParaRPr lang="en-US" sz="950" dirty="0"/>
           </a:p>
@@ -8129,7 +7889,7 @@
       </p:sp>
       <p:pic>
         <p:nvPicPr>
-          <p:cNvPr id="14" name="Image 3" descr="/Users/z5162865/WongLab/AlphaGenome_Ap1/Analysis/slide_figures/panels/s2_matched_null_c3_r0.png">    </p:cNvPr>
+          <p:cNvPr id="13" name="Image 3" descr="/Users/z5162865/WongLab/AlphaGenome_Ap1/Analysis/slide_figures/panels/s2_matched_null_c2_r0.png">    </p:cNvPr>
           <p:cNvPicPr>
             <a:picLocks noChangeAspect="1"/>
           </p:cNvPicPr>
@@ -8143,8 +7903,8 @@
         </p:blipFill>
         <p:spPr>
           <a:xfrm>
-            <a:off x="8897112" y="2079013"/>
-            <a:ext cx="2688336" cy="2443942"/>
+            <a:off x="6745529" y="3328416"/>
+            <a:ext cx="1468526" cy="1335024"/>
           </a:xfrm>
           <a:prstGeom prst="rect">
             <a:avLst/>
@@ -8153,13 +7913,109 @@
       </p:pic>
       <p:sp>
         <p:nvSpPr>
-          <p:cNvPr id="15" name="s2_matched_null-dot-0"/>
+          <p:cNvPr id="14" name="s2_matched_null-title-3"/>
+          <p:cNvSpPr txBox="1"/>
+          <p:nvPr/>
+        </p:nvSpPr>
+        <p:spPr>
+          <a:xfrm>
+            <a:off x="8897112" y="2578608"/>
+            <a:ext cx="2688336" cy="438912"/>
+          </a:xfrm>
+          <a:prstGeom prst="rect">
+            <a:avLst/>
+          </a:prstGeom>
+          <a:noFill/>
+          <a:ln/>
+        </p:spPr>
+        <p:txBody>
+          <a:bodyPr wrap="square" lIns="0" tIns="0" rIns="0" bIns="0" rtlCol="0" anchor="t"/>
+          <a:lstStyle/>
+          <a:p>
+            <a:pPr indent="0" marL="0">
+              <a:buNone/>
+            </a:pPr>
+            <a:r>
+              <a:rPr lang="en-US" sz="1250" b="1" dirty="0">
+                <a:solidFill>
+                  <a:srgbClr val="111111"/>
+                </a:solidFill>
+              </a:rPr>
+              <a:t>Edit 300 bp away</a:t>
+            </a:r>
+            <a:endParaRPr lang="en-US" sz="1250" dirty="0"/>
+          </a:p>
+        </p:txBody>
+      </p:sp>
+      <p:sp>
+        <p:nvSpPr>
+          <p:cNvPr id="15" name="s2_matched_null-sub-3"/>
+          <p:cNvSpPr txBox="1"/>
+          <p:nvPr/>
+        </p:nvSpPr>
+        <p:spPr>
+          <a:xfrm>
+            <a:off x="8897112" y="3008376"/>
+            <a:ext cx="2688336" cy="310896"/>
+          </a:xfrm>
+          <a:prstGeom prst="rect">
+            <a:avLst/>
+          </a:prstGeom>
+          <a:noFill/>
+          <a:ln/>
+        </p:spPr>
+        <p:txBody>
+          <a:bodyPr wrap="square" lIns="0" tIns="0" rIns="0" bIns="0" rtlCol="0" anchor="t"/>
+          <a:lstStyle/>
+          <a:p>
+            <a:pPr indent="0" marL="0">
+              <a:buNone/>
+            </a:pPr>
+            <a:r>
+              <a:rPr lang="en-US" sz="950" dirty="0">
+                <a:solidFill>
+                  <a:srgbClr val="595959"/>
+                </a:solidFill>
+              </a:rPr>
+              <a:t>the control: nothing at stake</a:t>
+            </a:r>
+            <a:endParaRPr lang="en-US" sz="950" dirty="0"/>
+          </a:p>
+        </p:txBody>
+      </p:sp>
+      <p:pic>
+        <p:nvPicPr>
+          <p:cNvPr id="16" name="Image 4" descr="/Users/z5162865/WongLab/AlphaGenome_Ap1/Analysis/slide_figures/panels/s2_matched_null_c3_r0.png">    </p:cNvPr>
+          <p:cNvPicPr>
+            <a:picLocks noChangeAspect="1"/>
+          </p:cNvPicPr>
+          <p:nvPr/>
+        </p:nvPicPr>
+        <p:blipFill>
+          <a:blip r:embed="rId5"/>
+          <a:stretch>
+            <a:fillRect/>
+          </a:stretch>
+        </p:blipFill>
+        <p:spPr>
+          <a:xfrm>
+            <a:off x="9507017" y="3328416"/>
+            <a:ext cx="1468526" cy="1335024"/>
+          </a:xfrm>
+          <a:prstGeom prst="rect">
+            <a:avLst/>
+          </a:prstGeom>
+        </p:spPr>
+      </p:pic>
+      <p:sp>
+        <p:nvSpPr>
+          <p:cNvPr id="17" name="s2_matched_null-dot-0"/>
           <p:cNvSpPr/>
           <p:nvPr/>
         </p:nvSpPr>
         <p:spPr>
           <a:xfrm>
-            <a:off x="502920" y="4914900"/>
+            <a:off x="502920" y="4869180"/>
             <a:ext cx="109728" cy="109728"/>
           </a:xfrm>
           <a:prstGeom prst="ellipse">
@@ -8178,13 +8034,13 @@
       </p:sp>
       <p:sp>
         <p:nvSpPr>
-          <p:cNvPr id="16" name="s2_matched_null-leg-0"/>
+          <p:cNvPr id="18" name="s2_matched_null-leg-0"/>
           <p:cNvSpPr txBox="1"/>
           <p:nvPr/>
         </p:nvSpPr>
         <p:spPr>
           <a:xfrm>
-            <a:off x="658368" y="4873752"/>
+            <a:off x="658368" y="4828032"/>
             <a:ext cx="1057046" cy="201168"/>
           </a:xfrm>
           <a:prstGeom prst="rect">
@@ -8214,13 +8070,13 @@
       </p:sp>
       <p:sp>
         <p:nvSpPr>
-          <p:cNvPr id="17" name="s2_matched_null-dot-1"/>
+          <p:cNvPr id="19" name="s2_matched_null-dot-1"/>
           <p:cNvSpPr/>
           <p:nvPr/>
         </p:nvSpPr>
         <p:spPr>
           <a:xfrm>
-            <a:off x="1825142" y="4914900"/>
+            <a:off x="1825142" y="4869180"/>
             <a:ext cx="109728" cy="109728"/>
           </a:xfrm>
           <a:prstGeom prst="ellipse">
@@ -8239,13 +8095,13 @@
       </p:sp>
       <p:sp>
         <p:nvSpPr>
-          <p:cNvPr id="18" name="s2_matched_null-leg-1"/>
+          <p:cNvPr id="20" name="s2_matched_null-leg-1"/>
           <p:cNvSpPr txBox="1"/>
           <p:nvPr/>
         </p:nvSpPr>
         <p:spPr>
           <a:xfrm>
-            <a:off x="1980590" y="4873752"/>
+            <a:off x="1980590" y="4828032"/>
             <a:ext cx="596189" cy="201168"/>
           </a:xfrm>
           <a:prstGeom prst="rect">
@@ -8275,13 +8131,13 @@
       </p:sp>
       <p:sp>
         <p:nvSpPr>
-          <p:cNvPr id="19" name="s2_matched_null-dot-2"/>
+          <p:cNvPr id="21" name="s2_matched_null-dot-2"/>
           <p:cNvSpPr/>
           <p:nvPr/>
         </p:nvSpPr>
         <p:spPr>
           <a:xfrm>
-            <a:off x="2686507" y="4914900"/>
+            <a:off x="2686507" y="4869180"/>
             <a:ext cx="109728" cy="109728"/>
           </a:xfrm>
           <a:prstGeom prst="ellipse">
@@ -8300,13 +8156,13 @@
       </p:sp>
       <p:sp>
         <p:nvSpPr>
-          <p:cNvPr id="20" name="s2_matched_null-leg-2"/>
+          <p:cNvPr id="22" name="s2_matched_null-leg-2"/>
           <p:cNvSpPr txBox="1"/>
           <p:nvPr/>
         </p:nvSpPr>
         <p:spPr>
           <a:xfrm>
-            <a:off x="2841955" y="4873752"/>
+            <a:off x="2841955" y="4828032"/>
             <a:ext cx="727862" cy="201168"/>
           </a:xfrm>
           <a:prstGeom prst="rect">
@@ -8336,13 +8192,13 @@
       </p:sp>
       <p:sp>
         <p:nvSpPr>
-          <p:cNvPr id="21" name="s2_matched_null-dot-3"/>
+          <p:cNvPr id="23" name="s2_matched_null-dot-3"/>
           <p:cNvSpPr/>
           <p:nvPr/>
         </p:nvSpPr>
         <p:spPr>
           <a:xfrm>
-            <a:off x="3679546" y="4914900"/>
+            <a:off x="3679546" y="4869180"/>
             <a:ext cx="109728" cy="109728"/>
           </a:xfrm>
           <a:prstGeom prst="ellipse">
@@ -8361,13 +8217,13 @@
       </p:sp>
       <p:sp>
         <p:nvSpPr>
-          <p:cNvPr id="22" name="s2_matched_null-leg-3"/>
+          <p:cNvPr id="24" name="s2_matched_null-leg-3"/>
           <p:cNvSpPr txBox="1"/>
           <p:nvPr/>
         </p:nvSpPr>
         <p:spPr>
           <a:xfrm>
-            <a:off x="3834994" y="4873752"/>
+            <a:off x="3834994" y="4828032"/>
             <a:ext cx="925373" cy="201168"/>
           </a:xfrm>
           <a:prstGeom prst="rect">
@@ -8397,13 +8253,13 @@
       </p:sp>
       <p:sp>
         <p:nvSpPr>
-          <p:cNvPr id="23" name="s2_matched_null-dot-4"/>
+          <p:cNvPr id="25" name="s2_matched_null-dot-4"/>
           <p:cNvSpPr/>
           <p:nvPr/>
         </p:nvSpPr>
         <p:spPr>
           <a:xfrm>
-            <a:off x="4870094" y="4914900"/>
+            <a:off x="4870094" y="4869180"/>
             <a:ext cx="109728" cy="109728"/>
           </a:xfrm>
           <a:prstGeom prst="ellipse">
@@ -8422,13 +8278,13 @@
       </p:sp>
       <p:sp>
         <p:nvSpPr>
-          <p:cNvPr id="24" name="s2_matched_null-leg-4"/>
+          <p:cNvPr id="26" name="s2_matched_null-leg-4"/>
           <p:cNvSpPr txBox="1"/>
           <p:nvPr/>
         </p:nvSpPr>
         <p:spPr>
           <a:xfrm>
-            <a:off x="5025542" y="4873752"/>
+            <a:off x="5025542" y="4828032"/>
             <a:ext cx="1057046" cy="201168"/>
           </a:xfrm>
           <a:prstGeom prst="rect">
@@ -8458,13 +8314,13 @@
       </p:sp>
       <p:sp>
         <p:nvSpPr>
-          <p:cNvPr id="25" name="s2_matched_null-dot-5"/>
+          <p:cNvPr id="27" name="s2_matched_null-dot-5"/>
           <p:cNvSpPr/>
           <p:nvPr/>
         </p:nvSpPr>
         <p:spPr>
           <a:xfrm>
-            <a:off x="6192317" y="4914900"/>
+            <a:off x="6192317" y="4869180"/>
             <a:ext cx="109728" cy="109728"/>
           </a:xfrm>
           <a:prstGeom prst="ellipse">
@@ -8483,13 +8339,13 @@
       </p:sp>
       <p:sp>
         <p:nvSpPr>
-          <p:cNvPr id="26" name="s2_matched_null-leg-5"/>
+          <p:cNvPr id="28" name="s2_matched_null-leg-5"/>
           <p:cNvSpPr txBox="1"/>
           <p:nvPr/>
         </p:nvSpPr>
         <p:spPr>
           <a:xfrm>
-            <a:off x="6347765" y="4873752"/>
+            <a:off x="6347765" y="4828032"/>
             <a:ext cx="1781251" cy="201168"/>
           </a:xfrm>
           <a:prstGeom prst="rect">
@@ -8519,13 +8375,13 @@
       </p:sp>
       <p:sp>
         <p:nvSpPr>
-          <p:cNvPr id="27" name="s2_matched_null-key"/>
+          <p:cNvPr id="29" name="s2_matched_null-key"/>
           <p:cNvSpPr txBox="1"/>
           <p:nvPr/>
         </p:nvSpPr>
         <p:spPr>
           <a:xfrm>
-            <a:off x="502920" y="5148072"/>
+            <a:off x="502920" y="5102352"/>
             <a:ext cx="11155680" cy="502920"/>
           </a:xfrm>
           <a:prstGeom prst="rect">
@@ -8555,7 +8411,7 @@
       </p:sp>
       <p:sp>
         <p:nvSpPr>
-          <p:cNvPr id="28" name="Text 0"/>
+          <p:cNvPr id="30" name="Text 0"/>
           <p:cNvSpPr/>
           <p:nvPr>
             <p:ph idx="101" type="body" hasCustomPrompt="1"/>

</xml_diff>

<commit_message>
Unclip the profile panels and say what "spread" means
Both profile panels were saving without a tight bounding box, so the y-axis
labels lost their closing bracket and the right-hand tick was cut. Saved tight
now, with shorter axis labels.

Spread was labelled only "SD of window position, weighted by loss", which does
not tell a reader what the number means. The subtitle now gives the weighting
explicitly and the speaker notes give the scale: all the loss in one window is
0 bp, the central 90 bp is 26, the central 170 bp is 49, spread evenly over the
whole 600 bp is 173. Observed values run 29 to 216 with a median of 87.

Co-Authored-By: Claude Opus 5 <noreply@anthropic.com>
</commit_message>
<xml_diff>
--- a/Analysis/AP1_AlphaGenome_results.pptx
+++ b/Analysis/AP1_AlphaGenome_results.pptx
@@ -122,19 +122,19 @@
   <p:extLst>
     <p:ext uri="{521415D9-36F7-43E2-AB2F-B90AF26B5E84}">
       <p14:sectionLst xmlns:p14="http://schemas.microsoft.com/office/powerpoint/2010/main">
-        <p14:section name="Opening" id="{b4670f3b-2581-cefe-17f0-6cadfd8135cb}">
+        <p14:section name="Opening" id="{9c34cc70-9536-c6db-ee69-3c55e578d846}">
           <p14:sldIdLst>
             <p14:sldId id="256"/>
           </p14:sldIdLst>
         </p14:section>
-        <p14:section name="Design" id="{d0a7aa40-f9fc-eb03-01c0-7d2abef8def0}">
+        <p14:section name="Design" id="{0f33ed6b-15a6-188f-503d-c2c5ea1bb9b8}">
           <p14:sldIdLst>
             <p14:sldId id="257"/>
             <p14:sldId id="258"/>
             <p14:sldId id="259"/>
           </p14:sldIdLst>
         </p14:section>
-        <p14:section name="Findings" id="{5f6d2a89-2256-453b-6324-a09fb860b719}">
+        <p14:section name="Findings" id="{183478aa-37fa-84be-a3ea-145a21d41cb9}">
           <p14:sldIdLst>
             <p14:sldId id="260"/>
             <p14:sldId id="261"/>
@@ -148,7 +148,7 @@
             <p14:sldId id="269"/>
           </p14:sldIdLst>
         </p14:section>
-        <p14:section name="Conclusion" id="{65a0044b-3162-4dde-0792-36e733bd482c}">
+        <p14:section name="Conclusion" id="{3cce498f-95e6-e4ce-f676-94798d9ed3a8}">
           <p14:sldIdLst>
             <p14:sldId id="270"/>
             <p14:sldId id="271"/>
@@ -734,7 +734,7 @@
           <a:p>
             <a:r>
               <a:rPr lang="en-US" dirty="0"/>
-              <a:t>The profiles are means, not medians, so the area under a curve equals the per-site totals in the panels on the right; with medians the two panels are different functions and do not correspond. Note where the difference lives: at the single deepest window Stable and Age Up are almost identical (0.68 vs 0.63 mean), and the 18% gap in loss within 85 bp comes from the shoulders, not the peak. At the core (within 15 bp) every class loses less than Stable sites do: Age Down 0.73x, Exercise Up 0.76x, Exercise Down 0.78x, Dynamic 0.80x, Age Up 0.90x, all FDR &lt;= 0.016. Normalised to each site’s own total, the core share is barely different (0.93-1.00) but the flank share beyond 85 bp is higher in Age Up 1.31x, Exercise Down 1.29x and Dynamic 1.21x, all FDR &lt;= 0.0002, while Age Down is 0.99x. So Age Down is not a redistribution, it is a weaker element throughout.</a:t>
+              <a:t>The profiles are means, not medians, so the area under a curve equals the per-site totals in the panels on the right; with medians the two panels are different functions and do not correspond. Note where the difference lives: at the single deepest window Stable and Age Up are almost identical (0.68 vs 0.63 mean), and the 18% gap in loss within 85 bp comes from the shoulders, not the peak. Spread is the standard deviation of window position when each of the 60 windows is weighted by its share of that site's total loss, measured about the centre of mass of the loss rather than about the motif. For scale: all the loss in one window gives 0 bp, confined to the central 90 bp gives 26, to the central 170 bp gives 49, and spread evenly over the whole 600 bp gives 173. Observed values run 29 to 216 with a median of 87, so a typical element draws on a window well over 100 bp wide.</a:t>
             </a:r>
             <a:endParaRPr lang="en-US" dirty="0"/>
           </a:p>
@@ -3183,7 +3183,7 @@
                   <a:srgbClr val="595959"/>
                 </a:solidFill>
               </a:rPr>
-              <a:t>mean loss at each of the 60 windows, smoothed over 3; summed across windows this is exactly the quantity in the panels on the right. Gold band = the ±15 bp core.</a:t>
+              <a:t>mean loss at each of the 60 windows, smoothed over 3 — summed across windows, exactly the quantity on the right. Gold = the ±15 bp core.</a:t>
             </a:r>
             <a:endParaRPr lang="en-US" sz="1050" dirty="0"/>
           </a:p>
@@ -3205,8 +3205,8 @@
         </p:blipFill>
         <p:spPr>
           <a:xfrm>
-            <a:off x="1139268" y="1609344"/>
-            <a:ext cx="5676744" cy="1783080"/>
+            <a:off x="1385461" y="1609344"/>
+            <a:ext cx="5184358" cy="1783080"/>
           </a:xfrm>
           <a:prstGeom prst="rect">
             <a:avLst/>
@@ -3301,8 +3301,8 @@
         </p:blipFill>
         <p:spPr>
           <a:xfrm>
-            <a:off x="1284825" y="3950208"/>
-            <a:ext cx="5385629" cy="1691640"/>
+            <a:off x="1489343" y="3950208"/>
+            <a:ext cx="4976595" cy="1691640"/>
           </a:xfrm>
           <a:prstGeom prst="rect">
             <a:avLst/>

</xml_diff>

<commit_message>
Record what spread means biologically, and that it is confounded with weakness
Spread reads naturally as "many contributors instead of one", but the data do
not support that reading. Across all 3,678 sites it tracks the Gini
concentration at rho -0.71 yet the number of windows that matter at only -0.22,
and the broadest fifth of sites have FEWER windows that matter than the tightest
fifth (5 vs 7), a shallower motif window (-0.44 vs -0.99) and less total loss
(6.4 vs 9.3).

So a broad profile means no stretch dominates, not that many stretches
contribute. The defensible sentence is that responsive elements have no dominant
anchor and their dependence is both weaker and more evenly scattered, which is
what the near-versus-far panels already show. Added to the speaker notes so the
question can be answered from the slide.

Co-Authored-By: Claude Opus 5 <noreply@anthropic.com>
</commit_message>
<xml_diff>
--- a/Analysis/AP1_AlphaGenome_results.pptx
+++ b/Analysis/AP1_AlphaGenome_results.pptx
@@ -122,19 +122,19 @@
   <p:extLst>
     <p:ext uri="{521415D9-36F7-43E2-AB2F-B90AF26B5E84}">
       <p14:sectionLst xmlns:p14="http://schemas.microsoft.com/office/powerpoint/2010/main">
-        <p14:section name="Opening" id="{9c34cc70-9536-c6db-ee69-3c55e578d846}">
+        <p14:section name="Opening" id="{4581dcb1-9e71-5a9a-1e1c-23c1ecc633a2}">
           <p14:sldIdLst>
             <p14:sldId id="256"/>
           </p14:sldIdLst>
         </p14:section>
-        <p14:section name="Design" id="{0f33ed6b-15a6-188f-503d-c2c5ea1bb9b8}">
+        <p14:section name="Design" id="{09048611-57fe-0156-068f-4b07f6697b58}">
           <p14:sldIdLst>
             <p14:sldId id="257"/>
             <p14:sldId id="258"/>
             <p14:sldId id="259"/>
           </p14:sldIdLst>
         </p14:section>
-        <p14:section name="Findings" id="{183478aa-37fa-84be-a3ea-145a21d41cb9}">
+        <p14:section name="Findings" id="{76a5de9e-a77f-da28-4959-403d99750845}">
           <p14:sldIdLst>
             <p14:sldId id="260"/>
             <p14:sldId id="261"/>
@@ -148,7 +148,7 @@
             <p14:sldId id="269"/>
           </p14:sldIdLst>
         </p14:section>
-        <p14:section name="Conclusion" id="{3cce498f-95e6-e4ce-f676-94798d9ed3a8}">
+        <p14:section name="Conclusion" id="{cebae3aa-5bb8-49b8-b7e0-60aaecf36be2}">
           <p14:sldIdLst>
             <p14:sldId id="270"/>
             <p14:sldId id="271"/>
@@ -734,7 +734,7 @@
           <a:p>
             <a:r>
               <a:rPr lang="en-US" dirty="0"/>
-              <a:t>The profiles are means, not medians, so the area under a curve equals the per-site totals in the panels on the right; with medians the two panels are different functions and do not correspond. Note where the difference lives: at the single deepest window Stable and Age Up are almost identical (0.68 vs 0.63 mean), and the 18% gap in loss within 85 bp comes from the shoulders, not the peak. Spread is the standard deviation of window position when each of the 60 windows is weighted by its share of that site's total loss, measured about the centre of mass of the loss rather than about the motif. For scale: all the loss in one window gives 0 bp, confined to the central 90 bp gives 26, to the central 170 bp gives 49, and spread evenly over the whole 600 bp gives 173. Observed values run 29 to 216 with a median of 87, so a typical element draws on a window well over 100 bp wide.</a:t>
+              <a:t>The profiles are means, not medians, so the area under a curve equals the per-site totals in the panels on the right; with medians the two panels are different functions and do not correspond. Note where the difference lives: at the single deepest window Stable and Age Up are almost identical (0.68 vs 0.63 mean), and the 18% gap in loss within 85 bp comes from the shoulders, not the peak. Spread is the standard deviation of window position when each of the 60 windows is weighted by its share of that site's total loss, measured about the centre of mass of the loss rather than about the motif. For scale: all the loss in one window gives 0 bp, confined to the central 90 bp gives 26, to the central 170 bp gives 49, and spread evenly over the whole 600 bp gives 173. Observed values run 29 to 216 with a median of 87, so a typical element draws on a region well over 100 bp wide. Caveat worth having ready: spread is partly confounded with weakness. Across all sites it correlates with the Gini concentration at rho -0.71, but with the NUMBER of windows that matter at only -0.22, and the broadest fifth of sites have FEWER windows that matter (5 vs 7), a shallower motif window (-0.44 vs -0.99) and less total loss (6.4 vs 9.3) than the tightest fifth. So a broad profile here means no stretch dominates, not that many stretches contribute. The honest sentence is that responsive elements have no dominant anchor -- their dependence is both weaker and more evenly scattered -- which is the same thing the near-versus-far panels say.</a:t>
             </a:r>
             <a:endParaRPr lang="en-US" dirty="0"/>
           </a:p>

</xml_diff>